<commit_message>
standard: add Data Handshake + Delivery Team slides (light, generic)
Re-skin two pages from a project proposal into the deck's light-slide design
language (off-white canvas, white cards, coral accents, Inter) and insert them
after Engagement models (now slides 9-10):

- The Data Handshake — ensuring certainty: two-card handshake (Your team /
  Mivada) over three load-cycle cards. Made generic; no customer name.
- Your delivery team: two org charts (Mivada + customer) as top node + role
  chips. Per-role descriptions removed so it fits; shared-roles note beneath.

Deck is now 18 slides. README story/counts updated.

https://claude.ai/code/session_013KakfoRwev8fSFVnXRjTeJ
</commit_message>
<xml_diff>
--- a/design-system/standard/Mivada_Standard.pptx
+++ b/design-system/standard/Mivada_Standard.pptx
@@ -16,6 +16,8 @@
     <p:sldId id="260" r:id="rId7"/>
     <p:sldId id="264" r:id="rId8"/>
     <p:sldId id="276" r:id="rId9"/>
+    <p:sldId id="278" r:id="rId23"/>
+    <p:sldId id="279" r:id="rId24"/>
     <p:sldId id="263" r:id="rId10"/>
     <p:sldId id="277" r:id="rId11"/>
     <p:sldId id="265" r:id="rId12"/>
@@ -9034,6 +9036,2759 @@
                 <a:latin typeface="Inter"/>
               </a:rPr>
               <a:t>Sydney · Melbourne · AU &amp; India</a:t>
+            </a:r>
+          </a:p>
+        </p:txBody>
+      </p:sp>
+    </p:spTree>
+  </p:cSld>
+  <p:clrMapOvr>
+    <a:masterClrMapping/>
+  </p:clrMapOvr>
+</p:sld>
+</file>
+
+<file path=ppt/slides/slide17.xml><?xml version="1.0" encoding="utf-8"?>
+<p:sld xmlns:a="http://schemas.openxmlformats.org/drawingml/2006/main" xmlns:p="http://schemas.openxmlformats.org/presentationml/2006/main" xmlns:r="http://schemas.openxmlformats.org/officeDocument/2006/relationships">
+  <p:cSld>
+    <p:bg>
+      <p:bgPr>
+        <a:solidFill>
+          <a:srgbClr val="FAFAFA"/>
+        </a:solidFill>
+        <a:effectLst/>
+      </p:bgPr>
+    </p:bg>
+    <p:spTree>
+      <p:nvGrpSpPr>
+        <p:cNvPr id="1" name=""/>
+        <p:cNvGrpSpPr/>
+        <p:nvPr/>
+      </p:nvGrpSpPr>
+      <p:grpSpPr/>
+      <p:pic>
+        <p:nvPicPr>
+          <p:cNvPr id="2" name="Picture 1" descr="image.png"/>
+          <p:cNvPicPr>
+            <a:picLocks noChangeAspect="1"/>
+          </p:cNvPicPr>
+          <p:nvPr/>
+        </p:nvPicPr>
+        <p:blipFill>
+          <a:blip r:embed="rId2"/>
+          <a:stretch>
+            <a:fillRect/>
+          </a:stretch>
+        </p:blipFill>
+        <p:spPr>
+          <a:xfrm>
+            <a:off x="877824" y="457200"/>
+            <a:ext cx="402336" cy="237744"/>
+          </a:xfrm>
+          <a:prstGeom prst="rect">
+            <a:avLst/>
+          </a:prstGeom>
+        </p:spPr>
+      </p:pic>
+      <p:sp>
+        <p:nvSpPr>
+          <p:cNvPr id="3" name="TextBox 2"/>
+          <p:cNvSpPr txBox="1"/>
+          <p:nvPr/>
+        </p:nvSpPr>
+        <p:spPr>
+          <a:xfrm>
+            <a:off x="5943600" y="420624"/>
+            <a:ext cx="5486400" cy="320040"/>
+          </a:xfrm>
+          <a:prstGeom prst="rect">
+            <a:avLst/>
+          </a:prstGeom>
+          <a:noFill/>
+        </p:spPr>
+        <p:txBody>
+          <a:bodyPr wrap="square" lIns="0" rIns="0" tIns="0" bIns="0" anchor="t">
+            <a:spAutoFit/>
+          </a:bodyPr>
+          <a:lstStyle/>
+          <a:p>
+            <a:pPr algn="r"/>
+            <a:r>
+              <a:rPr sz="1100" b="1">
+                <a:solidFill>
+                  <a:srgbClr val="EA493F"/>
+                </a:solidFill>
+                <a:latin typeface="Inter"/>
+              </a:rPr>
+              <a:t>DELIVERY APPROACH</a:t>
+            </a:r>
+          </a:p>
+        </p:txBody>
+      </p:sp>
+      <p:sp>
+        <p:nvSpPr>
+          <p:cNvPr id="4" name="TextBox 3"/>
+          <p:cNvSpPr txBox="1"/>
+          <p:nvPr/>
+        </p:nvSpPr>
+        <p:spPr>
+          <a:xfrm>
+            <a:off x="841248" y="896112"/>
+            <a:ext cx="10433304" cy="868680"/>
+          </a:xfrm>
+          <a:prstGeom prst="rect">
+            <a:avLst/>
+          </a:prstGeom>
+          <a:noFill/>
+        </p:spPr>
+        <p:txBody>
+          <a:bodyPr wrap="square" lIns="0" rIns="0" tIns="0" bIns="0" anchor="t">
+            <a:spAutoFit/>
+          </a:bodyPr>
+          <a:lstStyle/>
+          <a:p>
+            <a:pPr algn="l"/>
+            <a:r>
+              <a:rPr sz="3300" b="1">
+                <a:solidFill>
+                  <a:srgbClr val="111111"/>
+                </a:solidFill>
+                <a:latin typeface="Inter"/>
+              </a:rPr>
+              <a:t>The Data Handshake: </a:t>
+            </a:r>
+            <a:r>
+              <a:rPr sz="3300" b="1">
+                <a:solidFill>
+                  <a:srgbClr val="EA493F"/>
+                </a:solidFill>
+                <a:latin typeface="Inter"/>
+              </a:rPr>
+              <a:t>ensuring certainty.</a:t>
+            </a:r>
+          </a:p>
+        </p:txBody>
+      </p:sp>
+      <p:sp>
+        <p:nvSpPr>
+          <p:cNvPr id="5" name="TextBox 4"/>
+          <p:cNvSpPr txBox="1"/>
+          <p:nvPr/>
+        </p:nvSpPr>
+        <p:spPr>
+          <a:xfrm>
+            <a:off x="877824" y="1627632"/>
+            <a:ext cx="10442448" cy="502920"/>
+          </a:xfrm>
+          <a:prstGeom prst="rect">
+            <a:avLst/>
+          </a:prstGeom>
+          <a:noFill/>
+        </p:spPr>
+        <p:txBody>
+          <a:bodyPr wrap="square" lIns="0" rIns="0" tIns="0" bIns="0" anchor="t">
+            <a:spAutoFit/>
+          </a:bodyPr>
+          <a:lstStyle/>
+          <a:p>
+            <a:pPr algn="l">
+              <a:lnSpc>
+                <a:spcPct val="115000"/>
+              </a:lnSpc>
+            </a:pPr>
+            <a:r>
+              <a:rPr sz="1250" b="0">
+                <a:solidFill>
+                  <a:srgbClr val="323232"/>
+                </a:solidFill>
+                <a:latin typeface="Inter"/>
+              </a:rPr>
+              <a:t>Data is the fuel for your Workday engine — and accurate data is the only way to ensure operational success. We use a collaborative handshake model that plays to each side's strengths.</a:t>
+            </a:r>
+          </a:p>
+        </p:txBody>
+      </p:sp>
+      <p:sp>
+        <p:nvSpPr>
+          <p:cNvPr id="6" name="Rectangle 5"/>
+          <p:cNvSpPr/>
+          <p:nvPr/>
+        </p:nvSpPr>
+        <p:spPr>
+          <a:xfrm>
+            <a:off x="877824" y="2331720"/>
+            <a:ext cx="4736592" cy="1243584"/>
+          </a:xfrm>
+          <a:prstGeom prst="rect">
+            <a:avLst/>
+          </a:prstGeom>
+          <a:solidFill>
+            <a:srgbClr val="FFFFFF"/>
+          </a:solidFill>
+          <a:ln w="12700">
+            <a:solidFill>
+              <a:srgbClr val="E4E4E0"/>
+            </a:solidFill>
+          </a:ln>
+          <a:effectLst/>
+        </p:spPr>
+        <p:style>
+          <a:lnRef idx="1">
+            <a:schemeClr val="accent1"/>
+          </a:lnRef>
+          <a:fillRef idx="3">
+            <a:schemeClr val="accent1"/>
+          </a:fillRef>
+          <a:effectRef idx="2">
+            <a:schemeClr val="accent1"/>
+          </a:effectRef>
+          <a:fontRef idx="minor">
+            <a:schemeClr val="lt1"/>
+          </a:fontRef>
+        </p:style>
+        <p:txBody>
+          <a:bodyPr rtlCol="0" anchor="ctr" lIns="0" rIns="0"/>
+          <a:lstStyle/>
+          <a:p>
+            <a:pPr algn="ctr"/>
+          </a:p>
+        </p:txBody>
+      </p:sp>
+      <p:sp>
+        <p:nvSpPr>
+          <p:cNvPr id="7" name="Rectangle 6"/>
+          <p:cNvSpPr/>
+          <p:nvPr/>
+        </p:nvSpPr>
+        <p:spPr>
+          <a:xfrm>
+            <a:off x="6583680" y="2331720"/>
+            <a:ext cx="4736592" cy="1243584"/>
+          </a:xfrm>
+          <a:prstGeom prst="rect">
+            <a:avLst/>
+          </a:prstGeom>
+          <a:solidFill>
+            <a:srgbClr val="FFFFFF"/>
+          </a:solidFill>
+          <a:ln w="12700">
+            <a:solidFill>
+              <a:srgbClr val="E4E4E0"/>
+            </a:solidFill>
+          </a:ln>
+          <a:effectLst/>
+        </p:spPr>
+        <p:style>
+          <a:lnRef idx="1">
+            <a:schemeClr val="accent1"/>
+          </a:lnRef>
+          <a:fillRef idx="3">
+            <a:schemeClr val="accent1"/>
+          </a:fillRef>
+          <a:effectRef idx="2">
+            <a:schemeClr val="accent1"/>
+          </a:effectRef>
+          <a:fontRef idx="minor">
+            <a:schemeClr val="lt1"/>
+          </a:fontRef>
+        </p:style>
+        <p:txBody>
+          <a:bodyPr rtlCol="0" anchor="ctr" lIns="0" rIns="0"/>
+          <a:lstStyle/>
+          <a:p>
+            <a:pPr algn="ctr"/>
+          </a:p>
+        </p:txBody>
+      </p:sp>
+      <p:sp>
+        <p:nvSpPr>
+          <p:cNvPr id="8" name="TextBox 7"/>
+          <p:cNvSpPr txBox="1"/>
+          <p:nvPr/>
+        </p:nvSpPr>
+        <p:spPr>
+          <a:xfrm>
+            <a:off x="5614416" y="2331720"/>
+            <a:ext cx="969264" cy="1243584"/>
+          </a:xfrm>
+          <a:prstGeom prst="rect">
+            <a:avLst/>
+          </a:prstGeom>
+          <a:noFill/>
+        </p:spPr>
+        <p:txBody>
+          <a:bodyPr wrap="square" lIns="0" rIns="0" tIns="0" bIns="0" anchor="ctr">
+            <a:spAutoFit/>
+          </a:bodyPr>
+          <a:lstStyle/>
+          <a:p>
+            <a:pPr algn="ctr"/>
+            <a:r>
+              <a:rPr sz="3200" b="1">
+                <a:solidFill>
+                  <a:srgbClr val="EA493F"/>
+                </a:solidFill>
+                <a:latin typeface="Inter"/>
+              </a:rPr>
+              <a:t>↔</a:t>
+            </a:r>
+          </a:p>
+        </p:txBody>
+      </p:sp>
+      <p:sp>
+        <p:nvSpPr>
+          <p:cNvPr id="9" name="TextBox 8"/>
+          <p:cNvSpPr txBox="1"/>
+          <p:nvPr/>
+        </p:nvSpPr>
+        <p:spPr>
+          <a:xfrm>
+            <a:off x="1152144" y="2496312"/>
+            <a:ext cx="4206240" cy="274320"/>
+          </a:xfrm>
+          <a:prstGeom prst="rect">
+            <a:avLst/>
+          </a:prstGeom>
+          <a:noFill/>
+        </p:spPr>
+        <p:txBody>
+          <a:bodyPr wrap="square" lIns="0" rIns="0" tIns="0" bIns="0" anchor="t">
+            <a:spAutoFit/>
+          </a:bodyPr>
+          <a:lstStyle/>
+          <a:p>
+            <a:pPr algn="l"/>
+            <a:r>
+              <a:rPr sz="1050" b="1">
+                <a:solidFill>
+                  <a:srgbClr val="EA493F"/>
+                </a:solidFill>
+                <a:latin typeface="Inter"/>
+              </a:rPr>
+              <a:t>YOUR TEAM</a:t>
+            </a:r>
+          </a:p>
+        </p:txBody>
+      </p:sp>
+      <p:sp>
+        <p:nvSpPr>
+          <p:cNvPr id="10" name="TextBox 9"/>
+          <p:cNvSpPr txBox="1"/>
+          <p:nvPr/>
+        </p:nvSpPr>
+        <p:spPr>
+          <a:xfrm>
+            <a:off x="1152144" y="2752344"/>
+            <a:ext cx="4206240" cy="292608"/>
+          </a:xfrm>
+          <a:prstGeom prst="rect">
+            <a:avLst/>
+          </a:prstGeom>
+          <a:noFill/>
+        </p:spPr>
+        <p:txBody>
+          <a:bodyPr wrap="square" lIns="0" rIns="0" tIns="0" bIns="0" anchor="t">
+            <a:spAutoFit/>
+          </a:bodyPr>
+          <a:lstStyle/>
+          <a:p>
+            <a:pPr algn="l"/>
+            <a:r>
+              <a:rPr sz="1400" b="1">
+                <a:solidFill>
+                  <a:srgbClr val="111111"/>
+                </a:solidFill>
+                <a:latin typeface="Inter"/>
+              </a:rPr>
+              <a:t>You know your business</a:t>
+            </a:r>
+          </a:p>
+        </p:txBody>
+      </p:sp>
+      <p:sp>
+        <p:nvSpPr>
+          <p:cNvPr id="11" name="TextBox 10"/>
+          <p:cNvSpPr txBox="1"/>
+          <p:nvPr/>
+        </p:nvSpPr>
+        <p:spPr>
+          <a:xfrm>
+            <a:off x="1152144" y="3063239"/>
+            <a:ext cx="4206240" cy="457200"/>
+          </a:xfrm>
+          <a:prstGeom prst="rect">
+            <a:avLst/>
+          </a:prstGeom>
+          <a:noFill/>
+        </p:spPr>
+        <p:txBody>
+          <a:bodyPr wrap="square" lIns="0" rIns="0" tIns="0" bIns="0" anchor="t">
+            <a:spAutoFit/>
+          </a:bodyPr>
+          <a:lstStyle/>
+          <a:p>
+            <a:pPr algn="l">
+              <a:lnSpc>
+                <a:spcPct val="110000"/>
+              </a:lnSpc>
+            </a:pPr>
+            <a:r>
+              <a:rPr sz="1050" b="0">
+                <a:solidFill>
+                  <a:srgbClr val="323232"/>
+                </a:solidFill>
+                <a:latin typeface="Inter"/>
+              </a:rPr>
+              <a:t>Extract &amp; cleanse legacy data — ensuring only active, accurate records are migrated.</a:t>
+            </a:r>
+          </a:p>
+        </p:txBody>
+      </p:sp>
+      <p:sp>
+        <p:nvSpPr>
+          <p:cNvPr id="12" name="TextBox 11"/>
+          <p:cNvSpPr txBox="1"/>
+          <p:nvPr/>
+        </p:nvSpPr>
+        <p:spPr>
+          <a:xfrm>
+            <a:off x="6858000" y="2496312"/>
+            <a:ext cx="4206240" cy="274320"/>
+          </a:xfrm>
+          <a:prstGeom prst="rect">
+            <a:avLst/>
+          </a:prstGeom>
+          <a:noFill/>
+        </p:spPr>
+        <p:txBody>
+          <a:bodyPr wrap="square" lIns="0" rIns="0" tIns="0" bIns="0" anchor="t">
+            <a:spAutoFit/>
+          </a:bodyPr>
+          <a:lstStyle/>
+          <a:p>
+            <a:pPr algn="l"/>
+            <a:r>
+              <a:rPr sz="1050" b="1">
+                <a:solidFill>
+                  <a:srgbClr val="EA493F"/>
+                </a:solidFill>
+                <a:latin typeface="Inter"/>
+              </a:rPr>
+              <a:t>MIVADA</a:t>
+            </a:r>
+          </a:p>
+        </p:txBody>
+      </p:sp>
+      <p:sp>
+        <p:nvSpPr>
+          <p:cNvPr id="13" name="TextBox 12"/>
+          <p:cNvSpPr txBox="1"/>
+          <p:nvPr/>
+        </p:nvSpPr>
+        <p:spPr>
+          <a:xfrm>
+            <a:off x="6858000" y="2752344"/>
+            <a:ext cx="4206240" cy="292608"/>
+          </a:xfrm>
+          <a:prstGeom prst="rect">
+            <a:avLst/>
+          </a:prstGeom>
+          <a:noFill/>
+        </p:spPr>
+        <p:txBody>
+          <a:bodyPr wrap="square" lIns="0" rIns="0" tIns="0" bIns="0" anchor="t">
+            <a:spAutoFit/>
+          </a:bodyPr>
+          <a:lstStyle/>
+          <a:p>
+            <a:pPr algn="l"/>
+            <a:r>
+              <a:rPr sz="1400" b="1">
+                <a:solidFill>
+                  <a:srgbClr val="111111"/>
+                </a:solidFill>
+                <a:latin typeface="Inter"/>
+              </a:rPr>
+              <a:t>We know Workday</a:t>
+            </a:r>
+          </a:p>
+        </p:txBody>
+      </p:sp>
+      <p:sp>
+        <p:nvSpPr>
+          <p:cNvPr id="14" name="TextBox 13"/>
+          <p:cNvSpPr txBox="1"/>
+          <p:nvPr/>
+        </p:nvSpPr>
+        <p:spPr>
+          <a:xfrm>
+            <a:off x="6858000" y="3063239"/>
+            <a:ext cx="4206240" cy="457200"/>
+          </a:xfrm>
+          <a:prstGeom prst="rect">
+            <a:avLst/>
+          </a:prstGeom>
+          <a:noFill/>
+        </p:spPr>
+        <p:txBody>
+          <a:bodyPr wrap="square" lIns="0" rIns="0" tIns="0" bIns="0" anchor="t">
+            <a:spAutoFit/>
+          </a:bodyPr>
+          <a:lstStyle/>
+          <a:p>
+            <a:pPr algn="l">
+              <a:lnSpc>
+                <a:spcPct val="110000"/>
+              </a:lnSpc>
+            </a:pPr>
+            <a:r>
+              <a:rPr sz="1050" b="0">
+                <a:solidFill>
+                  <a:srgbClr val="323232"/>
+                </a:solidFill>
+                <a:latin typeface="Inter"/>
+              </a:rPr>
+              <a:t>Provide the mapping templates and technical tooling to load data into Workday's architecture.</a:t>
+            </a:r>
+          </a:p>
+        </p:txBody>
+      </p:sp>
+      <p:sp>
+        <p:nvSpPr>
+          <p:cNvPr id="15" name="TextBox 14"/>
+          <p:cNvSpPr txBox="1"/>
+          <p:nvPr/>
+        </p:nvSpPr>
+        <p:spPr>
+          <a:xfrm>
+            <a:off x="877824" y="3822191"/>
+            <a:ext cx="10442448" cy="365760"/>
+          </a:xfrm>
+          <a:prstGeom prst="rect">
+            <a:avLst/>
+          </a:prstGeom>
+          <a:noFill/>
+        </p:spPr>
+        <p:txBody>
+          <a:bodyPr wrap="square" lIns="0" rIns="0" tIns="0" bIns="0" anchor="t">
+            <a:spAutoFit/>
+          </a:bodyPr>
+          <a:lstStyle/>
+          <a:p>
+            <a:pPr algn="l"/>
+            <a:r>
+              <a:rPr sz="1700" b="1">
+                <a:solidFill>
+                  <a:srgbClr val="111111"/>
+                </a:solidFill>
+                <a:latin typeface="Inter"/>
+              </a:rPr>
+              <a:t>Iterative validation — </a:t>
+            </a:r>
+            <a:r>
+              <a:rPr sz="1700" b="1">
+                <a:solidFill>
+                  <a:srgbClr val="EA493F"/>
+                </a:solidFill>
+                <a:latin typeface="Inter"/>
+              </a:rPr>
+              <a:t>no “big-bang” loads.</a:t>
+            </a:r>
+          </a:p>
+        </p:txBody>
+      </p:sp>
+      <p:sp>
+        <p:nvSpPr>
+          <p:cNvPr id="16" name="TextBox 15"/>
+          <p:cNvSpPr txBox="1"/>
+          <p:nvPr/>
+        </p:nvSpPr>
+        <p:spPr>
+          <a:xfrm>
+            <a:off x="877824" y="4261104"/>
+            <a:ext cx="10442448" cy="365760"/>
+          </a:xfrm>
+          <a:prstGeom prst="rect">
+            <a:avLst/>
+          </a:prstGeom>
+          <a:noFill/>
+        </p:spPr>
+        <p:txBody>
+          <a:bodyPr wrap="square" lIns="0" rIns="0" tIns="0" bIns="0" anchor="t">
+            <a:spAutoFit/>
+          </a:bodyPr>
+          <a:lstStyle/>
+          <a:p>
+            <a:pPr algn="l">
+              <a:lnSpc>
+                <a:spcPct val="112000"/>
+              </a:lnSpc>
+            </a:pPr>
+            <a:r>
+              <a:rPr sz="1150" b="0">
+                <a:solidFill>
+                  <a:srgbClr val="323232"/>
+                </a:solidFill>
+                <a:latin typeface="Inter"/>
+              </a:rPr>
+              <a:t>Three distinct load cycles let your team validate the numbers repeatedly — so the system is commercially accurate on day one.</a:t>
+            </a:r>
+          </a:p>
+        </p:txBody>
+      </p:sp>
+      <p:sp>
+        <p:nvSpPr>
+          <p:cNvPr id="17" name="Rectangle 16"/>
+          <p:cNvSpPr/>
+          <p:nvPr/>
+        </p:nvSpPr>
+        <p:spPr>
+          <a:xfrm>
+            <a:off x="877824" y="4773168"/>
+            <a:ext cx="3236976" cy="1371600"/>
+          </a:xfrm>
+          <a:prstGeom prst="rect">
+            <a:avLst/>
+          </a:prstGeom>
+          <a:solidFill>
+            <a:srgbClr val="FFFFFF"/>
+          </a:solidFill>
+          <a:ln w="12700">
+            <a:solidFill>
+              <a:srgbClr val="E4E4E0"/>
+            </a:solidFill>
+          </a:ln>
+          <a:effectLst/>
+        </p:spPr>
+        <p:style>
+          <a:lnRef idx="1">
+            <a:schemeClr val="accent1"/>
+          </a:lnRef>
+          <a:fillRef idx="3">
+            <a:schemeClr val="accent1"/>
+          </a:fillRef>
+          <a:effectRef idx="2">
+            <a:schemeClr val="accent1"/>
+          </a:effectRef>
+          <a:fontRef idx="minor">
+            <a:schemeClr val="lt1"/>
+          </a:fontRef>
+        </p:style>
+        <p:txBody>
+          <a:bodyPr rtlCol="0" anchor="ctr" lIns="0" rIns="0"/>
+          <a:lstStyle/>
+          <a:p>
+            <a:pPr algn="ctr"/>
+          </a:p>
+        </p:txBody>
+      </p:sp>
+      <p:sp>
+        <p:nvSpPr>
+          <p:cNvPr id="18" name="TextBox 17"/>
+          <p:cNvSpPr txBox="1"/>
+          <p:nvPr/>
+        </p:nvSpPr>
+        <p:spPr>
+          <a:xfrm>
+            <a:off x="1133856" y="4919472"/>
+            <a:ext cx="1828800" cy="457200"/>
+          </a:xfrm>
+          <a:prstGeom prst="rect">
+            <a:avLst/>
+          </a:prstGeom>
+          <a:noFill/>
+        </p:spPr>
+        <p:txBody>
+          <a:bodyPr wrap="square" lIns="0" rIns="0" tIns="0" bIns="0" anchor="t">
+            <a:spAutoFit/>
+          </a:bodyPr>
+          <a:lstStyle/>
+          <a:p>
+            <a:pPr algn="l"/>
+            <a:r>
+              <a:rPr sz="2600" b="1">
+                <a:solidFill>
+                  <a:srgbClr val="EA493F"/>
+                </a:solidFill>
+                <a:latin typeface="Inter"/>
+              </a:rPr>
+              <a:t>01</a:t>
+            </a:r>
+          </a:p>
+        </p:txBody>
+      </p:sp>
+      <p:sp>
+        <p:nvSpPr>
+          <p:cNvPr id="19" name="TextBox 18"/>
+          <p:cNvSpPr txBox="1"/>
+          <p:nvPr/>
+        </p:nvSpPr>
+        <p:spPr>
+          <a:xfrm>
+            <a:off x="1133856" y="5376672"/>
+            <a:ext cx="2724912" cy="274320"/>
+          </a:xfrm>
+          <a:prstGeom prst="rect">
+            <a:avLst/>
+          </a:prstGeom>
+          <a:noFill/>
+        </p:spPr>
+        <p:txBody>
+          <a:bodyPr wrap="square" lIns="0" rIns="0" tIns="0" bIns="0" anchor="t">
+            <a:spAutoFit/>
+          </a:bodyPr>
+          <a:lstStyle/>
+          <a:p>
+            <a:pPr algn="l"/>
+            <a:r>
+              <a:rPr sz="1300" b="1">
+                <a:solidFill>
+                  <a:srgbClr val="111111"/>
+                </a:solidFill>
+                <a:latin typeface="Inter"/>
+              </a:rPr>
+              <a:t>First load</a:t>
+            </a:r>
+          </a:p>
+        </p:txBody>
+      </p:sp>
+      <p:sp>
+        <p:nvSpPr>
+          <p:cNvPr id="20" name="TextBox 19"/>
+          <p:cNvSpPr txBox="1"/>
+          <p:nvPr/>
+        </p:nvSpPr>
+        <p:spPr>
+          <a:xfrm>
+            <a:off x="1133856" y="5669279"/>
+            <a:ext cx="2724912" cy="457200"/>
+          </a:xfrm>
+          <a:prstGeom prst="rect">
+            <a:avLst/>
+          </a:prstGeom>
+          <a:noFill/>
+        </p:spPr>
+        <p:txBody>
+          <a:bodyPr wrap="square" lIns="0" rIns="0" tIns="0" bIns="0" anchor="t">
+            <a:spAutoFit/>
+          </a:bodyPr>
+          <a:lstStyle/>
+          <a:p>
+            <a:pPr algn="l">
+              <a:lnSpc>
+                <a:spcPct val="110000"/>
+              </a:lnSpc>
+            </a:pPr>
+            <a:r>
+              <a:rPr sz="950" b="0">
+                <a:solidFill>
+                  <a:srgbClr val="323232"/>
+                </a:solidFill>
+                <a:latin typeface="Inter"/>
+              </a:rPr>
+              <a:t>Initial migration on a sample set — validates mapping templates and surfaces transformation issues early.</a:t>
+            </a:r>
+          </a:p>
+        </p:txBody>
+      </p:sp>
+      <p:sp>
+        <p:nvSpPr>
+          <p:cNvPr id="21" name="Rectangle 20"/>
+          <p:cNvSpPr/>
+          <p:nvPr/>
+        </p:nvSpPr>
+        <p:spPr>
+          <a:xfrm>
+            <a:off x="4480560" y="4773168"/>
+            <a:ext cx="3236976" cy="1371600"/>
+          </a:xfrm>
+          <a:prstGeom prst="rect">
+            <a:avLst/>
+          </a:prstGeom>
+          <a:solidFill>
+            <a:srgbClr val="FFFFFF"/>
+          </a:solidFill>
+          <a:ln w="12700">
+            <a:solidFill>
+              <a:srgbClr val="E4E4E0"/>
+            </a:solidFill>
+          </a:ln>
+          <a:effectLst/>
+        </p:spPr>
+        <p:style>
+          <a:lnRef idx="1">
+            <a:schemeClr val="accent1"/>
+          </a:lnRef>
+          <a:fillRef idx="3">
+            <a:schemeClr val="accent1"/>
+          </a:fillRef>
+          <a:effectRef idx="2">
+            <a:schemeClr val="accent1"/>
+          </a:effectRef>
+          <a:fontRef idx="minor">
+            <a:schemeClr val="lt1"/>
+          </a:fontRef>
+        </p:style>
+        <p:txBody>
+          <a:bodyPr rtlCol="0" anchor="ctr" lIns="0" rIns="0"/>
+          <a:lstStyle/>
+          <a:p>
+            <a:pPr algn="ctr"/>
+          </a:p>
+        </p:txBody>
+      </p:sp>
+      <p:sp>
+        <p:nvSpPr>
+          <p:cNvPr id="22" name="TextBox 21"/>
+          <p:cNvSpPr txBox="1"/>
+          <p:nvPr/>
+        </p:nvSpPr>
+        <p:spPr>
+          <a:xfrm>
+            <a:off x="4736592" y="4919472"/>
+            <a:ext cx="1828800" cy="457200"/>
+          </a:xfrm>
+          <a:prstGeom prst="rect">
+            <a:avLst/>
+          </a:prstGeom>
+          <a:noFill/>
+        </p:spPr>
+        <p:txBody>
+          <a:bodyPr wrap="square" lIns="0" rIns="0" tIns="0" bIns="0" anchor="t">
+            <a:spAutoFit/>
+          </a:bodyPr>
+          <a:lstStyle/>
+          <a:p>
+            <a:pPr algn="l"/>
+            <a:r>
+              <a:rPr sz="2600" b="1">
+                <a:solidFill>
+                  <a:srgbClr val="EA493F"/>
+                </a:solidFill>
+                <a:latin typeface="Inter"/>
+              </a:rPr>
+              <a:t>02</a:t>
+            </a:r>
+          </a:p>
+        </p:txBody>
+      </p:sp>
+      <p:sp>
+        <p:nvSpPr>
+          <p:cNvPr id="23" name="TextBox 22"/>
+          <p:cNvSpPr txBox="1"/>
+          <p:nvPr/>
+        </p:nvSpPr>
+        <p:spPr>
+          <a:xfrm>
+            <a:off x="4736592" y="5376672"/>
+            <a:ext cx="2724912" cy="274320"/>
+          </a:xfrm>
+          <a:prstGeom prst="rect">
+            <a:avLst/>
+          </a:prstGeom>
+          <a:noFill/>
+        </p:spPr>
+        <p:txBody>
+          <a:bodyPr wrap="square" lIns="0" rIns="0" tIns="0" bIns="0" anchor="t">
+            <a:spAutoFit/>
+          </a:bodyPr>
+          <a:lstStyle/>
+          <a:p>
+            <a:pPr algn="l"/>
+            <a:r>
+              <a:rPr sz="1300" b="1">
+                <a:solidFill>
+                  <a:srgbClr val="111111"/>
+                </a:solidFill>
+                <a:latin typeface="Inter"/>
+              </a:rPr>
+              <a:t>Second load</a:t>
+            </a:r>
+          </a:p>
+        </p:txBody>
+      </p:sp>
+      <p:sp>
+        <p:nvSpPr>
+          <p:cNvPr id="24" name="TextBox 23"/>
+          <p:cNvSpPr txBox="1"/>
+          <p:nvPr/>
+        </p:nvSpPr>
+        <p:spPr>
+          <a:xfrm>
+            <a:off x="4736592" y="5669279"/>
+            <a:ext cx="2724912" cy="457200"/>
+          </a:xfrm>
+          <a:prstGeom prst="rect">
+            <a:avLst/>
+          </a:prstGeom>
+          <a:noFill/>
+        </p:spPr>
+        <p:txBody>
+          <a:bodyPr wrap="square" lIns="0" rIns="0" tIns="0" bIns="0" anchor="t">
+            <a:spAutoFit/>
+          </a:bodyPr>
+          <a:lstStyle/>
+          <a:p>
+            <a:pPr algn="l">
+              <a:lnSpc>
+                <a:spcPct val="110000"/>
+              </a:lnSpc>
+            </a:pPr>
+            <a:r>
+              <a:rPr sz="950" b="0">
+                <a:solidFill>
+                  <a:srgbClr val="323232"/>
+                </a:solidFill>
+                <a:latin typeface="Inter"/>
+              </a:rPr>
+              <a:t>Full dataset migration. Your team validates balances, org structures and employee records against source.</a:t>
+            </a:r>
+          </a:p>
+        </p:txBody>
+      </p:sp>
+      <p:sp>
+        <p:nvSpPr>
+          <p:cNvPr id="25" name="Rectangle 24"/>
+          <p:cNvSpPr/>
+          <p:nvPr/>
+        </p:nvSpPr>
+        <p:spPr>
+          <a:xfrm>
+            <a:off x="8083296" y="4773168"/>
+            <a:ext cx="3236976" cy="1371600"/>
+          </a:xfrm>
+          <a:prstGeom prst="rect">
+            <a:avLst/>
+          </a:prstGeom>
+          <a:solidFill>
+            <a:srgbClr val="FFFFFF"/>
+          </a:solidFill>
+          <a:ln w="12700">
+            <a:solidFill>
+              <a:srgbClr val="E4E4E0"/>
+            </a:solidFill>
+          </a:ln>
+          <a:effectLst/>
+        </p:spPr>
+        <p:style>
+          <a:lnRef idx="1">
+            <a:schemeClr val="accent1"/>
+          </a:lnRef>
+          <a:fillRef idx="3">
+            <a:schemeClr val="accent1"/>
+          </a:fillRef>
+          <a:effectRef idx="2">
+            <a:schemeClr val="accent1"/>
+          </a:effectRef>
+          <a:fontRef idx="minor">
+            <a:schemeClr val="lt1"/>
+          </a:fontRef>
+        </p:style>
+        <p:txBody>
+          <a:bodyPr rtlCol="0" anchor="ctr" lIns="0" rIns="0"/>
+          <a:lstStyle/>
+          <a:p>
+            <a:pPr algn="ctr"/>
+          </a:p>
+        </p:txBody>
+      </p:sp>
+      <p:sp>
+        <p:nvSpPr>
+          <p:cNvPr id="26" name="TextBox 25"/>
+          <p:cNvSpPr txBox="1"/>
+          <p:nvPr/>
+        </p:nvSpPr>
+        <p:spPr>
+          <a:xfrm>
+            <a:off x="8339327" y="4919472"/>
+            <a:ext cx="1828800" cy="457200"/>
+          </a:xfrm>
+          <a:prstGeom prst="rect">
+            <a:avLst/>
+          </a:prstGeom>
+          <a:noFill/>
+        </p:spPr>
+        <p:txBody>
+          <a:bodyPr wrap="square" lIns="0" rIns="0" tIns="0" bIns="0" anchor="t">
+            <a:spAutoFit/>
+          </a:bodyPr>
+          <a:lstStyle/>
+          <a:p>
+            <a:pPr algn="l"/>
+            <a:r>
+              <a:rPr sz="2600" b="1">
+                <a:solidFill>
+                  <a:srgbClr val="EA493F"/>
+                </a:solidFill>
+                <a:latin typeface="Inter"/>
+              </a:rPr>
+              <a:t>03</a:t>
+            </a:r>
+          </a:p>
+        </p:txBody>
+      </p:sp>
+      <p:sp>
+        <p:nvSpPr>
+          <p:cNvPr id="27" name="TextBox 26"/>
+          <p:cNvSpPr txBox="1"/>
+          <p:nvPr/>
+        </p:nvSpPr>
+        <p:spPr>
+          <a:xfrm>
+            <a:off x="8339327" y="5376672"/>
+            <a:ext cx="2724912" cy="274320"/>
+          </a:xfrm>
+          <a:prstGeom prst="rect">
+            <a:avLst/>
+          </a:prstGeom>
+          <a:noFill/>
+        </p:spPr>
+        <p:txBody>
+          <a:bodyPr wrap="square" lIns="0" rIns="0" tIns="0" bIns="0" anchor="t">
+            <a:spAutoFit/>
+          </a:bodyPr>
+          <a:lstStyle/>
+          <a:p>
+            <a:pPr algn="l"/>
+            <a:r>
+              <a:rPr sz="1300" b="1">
+                <a:solidFill>
+                  <a:srgbClr val="111111"/>
+                </a:solidFill>
+                <a:latin typeface="Inter"/>
+              </a:rPr>
+              <a:t>Gold build</a:t>
+            </a:r>
+          </a:p>
+        </p:txBody>
+      </p:sp>
+      <p:sp>
+        <p:nvSpPr>
+          <p:cNvPr id="28" name="TextBox 27"/>
+          <p:cNvSpPr txBox="1"/>
+          <p:nvPr/>
+        </p:nvSpPr>
+        <p:spPr>
+          <a:xfrm>
+            <a:off x="8339327" y="5669279"/>
+            <a:ext cx="2724912" cy="457200"/>
+          </a:xfrm>
+          <a:prstGeom prst="rect">
+            <a:avLst/>
+          </a:prstGeom>
+          <a:noFill/>
+        </p:spPr>
+        <p:txBody>
+          <a:bodyPr wrap="square" lIns="0" rIns="0" tIns="0" bIns="0" anchor="t">
+            <a:spAutoFit/>
+          </a:bodyPr>
+          <a:lstStyle/>
+          <a:p>
+            <a:pPr algn="l">
+              <a:lnSpc>
+                <a:spcPct val="110000"/>
+              </a:lnSpc>
+            </a:pPr>
+            <a:r>
+              <a:rPr sz="950" b="0">
+                <a:solidFill>
+                  <a:srgbClr val="323232"/>
+                </a:solidFill>
+                <a:latin typeface="Inter"/>
+              </a:rPr>
+              <a:t>Final production load with current-state data — a point-in-time cutover, signed off before go-live.</a:t>
+            </a:r>
+          </a:p>
+        </p:txBody>
+      </p:sp>
+    </p:spTree>
+  </p:cSld>
+  <p:clrMapOvr>
+    <a:masterClrMapping/>
+  </p:clrMapOvr>
+</p:sld>
+</file>
+
+<file path=ppt/slides/slide18.xml><?xml version="1.0" encoding="utf-8"?>
+<p:sld xmlns:a="http://schemas.openxmlformats.org/drawingml/2006/main" xmlns:p="http://schemas.openxmlformats.org/presentationml/2006/main" xmlns:r="http://schemas.openxmlformats.org/officeDocument/2006/relationships">
+  <p:cSld>
+    <p:bg>
+      <p:bgPr>
+        <a:solidFill>
+          <a:srgbClr val="FAFAFA"/>
+        </a:solidFill>
+        <a:effectLst/>
+      </p:bgPr>
+    </p:bg>
+    <p:spTree>
+      <p:nvGrpSpPr>
+        <p:cNvPr id="1" name=""/>
+        <p:cNvGrpSpPr/>
+        <p:nvPr/>
+      </p:nvGrpSpPr>
+      <p:grpSpPr/>
+      <p:pic>
+        <p:nvPicPr>
+          <p:cNvPr id="2" name="Picture 1" descr="image.png"/>
+          <p:cNvPicPr>
+            <a:picLocks noChangeAspect="1"/>
+          </p:cNvPicPr>
+          <p:nvPr/>
+        </p:nvPicPr>
+        <p:blipFill>
+          <a:blip r:embed="rId2"/>
+          <a:stretch>
+            <a:fillRect/>
+          </a:stretch>
+        </p:blipFill>
+        <p:spPr>
+          <a:xfrm>
+            <a:off x="877824" y="457200"/>
+            <a:ext cx="402336" cy="237744"/>
+          </a:xfrm>
+          <a:prstGeom prst="rect">
+            <a:avLst/>
+          </a:prstGeom>
+        </p:spPr>
+      </p:pic>
+      <p:sp>
+        <p:nvSpPr>
+          <p:cNvPr id="3" name="TextBox 2"/>
+          <p:cNvSpPr txBox="1"/>
+          <p:nvPr/>
+        </p:nvSpPr>
+        <p:spPr>
+          <a:xfrm>
+            <a:off x="5943600" y="420624"/>
+            <a:ext cx="5486400" cy="320040"/>
+          </a:xfrm>
+          <a:prstGeom prst="rect">
+            <a:avLst/>
+          </a:prstGeom>
+          <a:noFill/>
+        </p:spPr>
+        <p:txBody>
+          <a:bodyPr wrap="square" lIns="0" rIns="0" tIns="0" bIns="0" anchor="t">
+            <a:spAutoFit/>
+          </a:bodyPr>
+          <a:lstStyle/>
+          <a:p>
+            <a:pPr algn="r"/>
+            <a:r>
+              <a:rPr sz="1100" b="1">
+                <a:solidFill>
+                  <a:srgbClr val="EA493F"/>
+                </a:solidFill>
+                <a:latin typeface="Inter"/>
+              </a:rPr>
+              <a:t>THE ONE TEAM</a:t>
+            </a:r>
+          </a:p>
+        </p:txBody>
+      </p:sp>
+      <p:sp>
+        <p:nvSpPr>
+          <p:cNvPr id="4" name="TextBox 3"/>
+          <p:cNvSpPr txBox="1"/>
+          <p:nvPr/>
+        </p:nvSpPr>
+        <p:spPr>
+          <a:xfrm>
+            <a:off x="841248" y="896112"/>
+            <a:ext cx="10433304" cy="868680"/>
+          </a:xfrm>
+          <a:prstGeom prst="rect">
+            <a:avLst/>
+          </a:prstGeom>
+          <a:noFill/>
+        </p:spPr>
+        <p:txBody>
+          <a:bodyPr wrap="square" lIns="0" rIns="0" tIns="0" bIns="0" anchor="t">
+            <a:spAutoFit/>
+          </a:bodyPr>
+          <a:lstStyle/>
+          <a:p>
+            <a:pPr algn="l"/>
+            <a:r>
+              <a:rPr sz="3300" b="1">
+                <a:solidFill>
+                  <a:srgbClr val="111111"/>
+                </a:solidFill>
+                <a:latin typeface="Inter"/>
+              </a:rPr>
+              <a:t>Your delivery </a:t>
+            </a:r>
+            <a:r>
+              <a:rPr sz="3300" b="1">
+                <a:solidFill>
+                  <a:srgbClr val="EA493F"/>
+                </a:solidFill>
+                <a:latin typeface="Inter"/>
+              </a:rPr>
+              <a:t>team.</a:t>
+            </a:r>
+          </a:p>
+        </p:txBody>
+      </p:sp>
+      <p:sp>
+        <p:nvSpPr>
+          <p:cNvPr id="5" name="TextBox 4"/>
+          <p:cNvSpPr txBox="1"/>
+          <p:nvPr/>
+        </p:nvSpPr>
+        <p:spPr>
+          <a:xfrm>
+            <a:off x="877824" y="1591056"/>
+            <a:ext cx="10442448" cy="457200"/>
+          </a:xfrm>
+          <a:prstGeom prst="rect">
+            <a:avLst/>
+          </a:prstGeom>
+          <a:noFill/>
+        </p:spPr>
+        <p:txBody>
+          <a:bodyPr wrap="square" lIns="0" rIns="0" tIns="0" bIns="0" anchor="t">
+            <a:spAutoFit/>
+          </a:bodyPr>
+          <a:lstStyle/>
+          <a:p>
+            <a:pPr algn="l">
+              <a:lnSpc>
+                <a:spcPct val="115000"/>
+              </a:lnSpc>
+            </a:pPr>
+            <a:r>
+              <a:rPr sz="1250" b="0">
+                <a:solidFill>
+                  <a:srgbClr val="323232"/>
+                </a:solidFill>
+                <a:latin typeface="Inter"/>
+              </a:rPr>
+              <a:t>Defined expertise across every layer of delivery — clear ownership, no gaps, no ambiguity, built on a “one team” model.</a:t>
+            </a:r>
+          </a:p>
+        </p:txBody>
+      </p:sp>
+      <p:sp>
+        <p:nvSpPr>
+          <p:cNvPr id="6" name="Rectangle 5"/>
+          <p:cNvSpPr/>
+          <p:nvPr/>
+        </p:nvSpPr>
+        <p:spPr>
+          <a:xfrm>
+            <a:off x="877824" y="2194560"/>
+            <a:ext cx="5029200" cy="2395728"/>
+          </a:xfrm>
+          <a:prstGeom prst="rect">
+            <a:avLst/>
+          </a:prstGeom>
+          <a:solidFill>
+            <a:srgbClr val="FFFFFF"/>
+          </a:solidFill>
+          <a:ln w="12700">
+            <a:solidFill>
+              <a:srgbClr val="E4E4E0"/>
+            </a:solidFill>
+          </a:ln>
+          <a:effectLst/>
+        </p:spPr>
+        <p:style>
+          <a:lnRef idx="1">
+            <a:schemeClr val="accent1"/>
+          </a:lnRef>
+          <a:fillRef idx="3">
+            <a:schemeClr val="accent1"/>
+          </a:fillRef>
+          <a:effectRef idx="2">
+            <a:schemeClr val="accent1"/>
+          </a:effectRef>
+          <a:fontRef idx="minor">
+            <a:schemeClr val="lt1"/>
+          </a:fontRef>
+        </p:style>
+        <p:txBody>
+          <a:bodyPr rtlCol="0" anchor="ctr" lIns="0" rIns="0"/>
+          <a:lstStyle/>
+          <a:p>
+            <a:pPr algn="ctr"/>
+          </a:p>
+        </p:txBody>
+      </p:sp>
+      <p:sp>
+        <p:nvSpPr>
+          <p:cNvPr id="7" name="TextBox 6"/>
+          <p:cNvSpPr txBox="1"/>
+          <p:nvPr/>
+        </p:nvSpPr>
+        <p:spPr>
+          <a:xfrm>
+            <a:off x="1152144" y="2377440"/>
+            <a:ext cx="4480560" cy="256032"/>
+          </a:xfrm>
+          <a:prstGeom prst="rect">
+            <a:avLst/>
+          </a:prstGeom>
+          <a:noFill/>
+        </p:spPr>
+        <p:txBody>
+          <a:bodyPr wrap="square" lIns="0" rIns="0" tIns="0" bIns="0" anchor="t">
+            <a:spAutoFit/>
+          </a:bodyPr>
+          <a:lstStyle/>
+          <a:p>
+            <a:pPr algn="ctr"/>
+            <a:r>
+              <a:rPr sz="950" b="1">
+                <a:solidFill>
+                  <a:srgbClr val="EA493F"/>
+                </a:solidFill>
+                <a:latin typeface="Inter"/>
+              </a:rPr>
+              <a:t>MIVADA DELIVERY TEAM</a:t>
+            </a:r>
+          </a:p>
+        </p:txBody>
+      </p:sp>
+      <p:sp>
+        <p:nvSpPr>
+          <p:cNvPr id="8" name="Rectangle 7"/>
+          <p:cNvSpPr/>
+          <p:nvPr/>
+        </p:nvSpPr>
+        <p:spPr>
+          <a:xfrm>
+            <a:off x="2249424" y="2761488"/>
+            <a:ext cx="2286000" cy="457200"/>
+          </a:xfrm>
+          <a:prstGeom prst="rect">
+            <a:avLst/>
+          </a:prstGeom>
+          <a:solidFill>
+            <a:srgbClr val="EA493F"/>
+          </a:solidFill>
+          <a:ln>
+            <a:noFill/>
+          </a:ln>
+          <a:effectLst/>
+        </p:spPr>
+        <p:style>
+          <a:lnRef idx="1">
+            <a:schemeClr val="accent1"/>
+          </a:lnRef>
+          <a:fillRef idx="3">
+            <a:schemeClr val="accent1"/>
+          </a:fillRef>
+          <a:effectRef idx="2">
+            <a:schemeClr val="accent1"/>
+          </a:effectRef>
+          <a:fontRef idx="minor">
+            <a:schemeClr val="lt1"/>
+          </a:fontRef>
+        </p:style>
+        <p:txBody>
+          <a:bodyPr rtlCol="0" anchor="ctr" lIns="0" rIns="0"/>
+          <a:lstStyle/>
+          <a:p>
+            <a:pPr algn="ctr"/>
+          </a:p>
+        </p:txBody>
+      </p:sp>
+      <p:sp>
+        <p:nvSpPr>
+          <p:cNvPr id="9" name="TextBox 8"/>
+          <p:cNvSpPr txBox="1"/>
+          <p:nvPr/>
+        </p:nvSpPr>
+        <p:spPr>
+          <a:xfrm>
+            <a:off x="2249424" y="2761488"/>
+            <a:ext cx="2286000" cy="457200"/>
+          </a:xfrm>
+          <a:prstGeom prst="rect">
+            <a:avLst/>
+          </a:prstGeom>
+          <a:noFill/>
+        </p:spPr>
+        <p:txBody>
+          <a:bodyPr wrap="square" lIns="0" rIns="0" tIns="0" bIns="0" anchor="ctr">
+            <a:spAutoFit/>
+          </a:bodyPr>
+          <a:lstStyle/>
+          <a:p>
+            <a:pPr algn="ctr"/>
+            <a:r>
+              <a:rPr sz="1200" b="1">
+                <a:solidFill>
+                  <a:srgbClr val="FFFFFF"/>
+                </a:solidFill>
+                <a:latin typeface="Inter"/>
+              </a:rPr>
+              <a:t>Client Partner</a:t>
+            </a:r>
+          </a:p>
+        </p:txBody>
+      </p:sp>
+      <p:cxnSp>
+        <p:nvCxnSpPr>
+          <p:cNvPr id="10" name="Connector 9"/>
+          <p:cNvCxnSpPr/>
+          <p:nvPr/>
+        </p:nvCxnSpPr>
+        <p:spPr>
+          <a:xfrm>
+            <a:off x="3392424" y="3218688"/>
+            <a:ext cx="0" cy="256032"/>
+          </a:xfrm>
+          <a:prstGeom prst="line">
+            <a:avLst/>
+          </a:prstGeom>
+          <a:ln w="12700">
+            <a:solidFill>
+              <a:srgbClr val="AEAEAE"/>
+            </a:solidFill>
+          </a:ln>
+          <a:effectLst/>
+        </p:spPr>
+        <p:style>
+          <a:lnRef idx="2">
+            <a:schemeClr val="accent1"/>
+          </a:lnRef>
+          <a:fillRef idx="0">
+            <a:schemeClr val="accent1"/>
+          </a:fillRef>
+          <a:effectRef idx="1">
+            <a:schemeClr val="accent1"/>
+          </a:effectRef>
+          <a:fontRef idx="minor">
+            <a:schemeClr val="tx1"/>
+          </a:fontRef>
+        </p:style>
+      </p:cxnSp>
+      <p:cxnSp>
+        <p:nvCxnSpPr>
+          <p:cNvPr id="11" name="Connector 10"/>
+          <p:cNvCxnSpPr/>
+          <p:nvPr/>
+        </p:nvCxnSpPr>
+        <p:spPr>
+          <a:xfrm>
+            <a:off x="1837943" y="3474720"/>
+            <a:ext cx="3108960" cy="0"/>
+          </a:xfrm>
+          <a:prstGeom prst="line">
+            <a:avLst/>
+          </a:prstGeom>
+          <a:ln w="12700">
+            <a:solidFill>
+              <a:srgbClr val="AEAEAE"/>
+            </a:solidFill>
+          </a:ln>
+          <a:effectLst/>
+        </p:spPr>
+        <p:style>
+          <a:lnRef idx="2">
+            <a:schemeClr val="accent1"/>
+          </a:lnRef>
+          <a:fillRef idx="0">
+            <a:schemeClr val="accent1"/>
+          </a:fillRef>
+          <a:effectRef idx="1">
+            <a:schemeClr val="accent1"/>
+          </a:effectRef>
+          <a:fontRef idx="minor">
+            <a:schemeClr val="tx1"/>
+          </a:fontRef>
+        </p:style>
+      </p:cxnSp>
+      <p:cxnSp>
+        <p:nvCxnSpPr>
+          <p:cNvPr id="12" name="Connector 11"/>
+          <p:cNvCxnSpPr/>
+          <p:nvPr/>
+        </p:nvCxnSpPr>
+        <p:spPr>
+          <a:xfrm>
+            <a:off x="1837943" y="3474720"/>
+            <a:ext cx="0" cy="347471"/>
+          </a:xfrm>
+          <a:prstGeom prst="line">
+            <a:avLst/>
+          </a:prstGeom>
+          <a:ln w="12700">
+            <a:solidFill>
+              <a:srgbClr val="AEAEAE"/>
+            </a:solidFill>
+          </a:ln>
+          <a:effectLst/>
+        </p:spPr>
+        <p:style>
+          <a:lnRef idx="2">
+            <a:schemeClr val="accent1"/>
+          </a:lnRef>
+          <a:fillRef idx="0">
+            <a:schemeClr val="accent1"/>
+          </a:fillRef>
+          <a:effectRef idx="1">
+            <a:schemeClr val="accent1"/>
+          </a:effectRef>
+          <a:fontRef idx="minor">
+            <a:schemeClr val="tx1"/>
+          </a:fontRef>
+        </p:style>
+      </p:cxnSp>
+      <p:sp>
+        <p:nvSpPr>
+          <p:cNvPr id="13" name="Rectangle 12"/>
+          <p:cNvSpPr/>
+          <p:nvPr/>
+        </p:nvSpPr>
+        <p:spPr>
+          <a:xfrm>
+            <a:off x="1133856" y="3822191"/>
+            <a:ext cx="1408175" cy="566928"/>
+          </a:xfrm>
+          <a:prstGeom prst="rect">
+            <a:avLst/>
+          </a:prstGeom>
+          <a:solidFill>
+            <a:srgbClr val="FFFFFF"/>
+          </a:solidFill>
+          <a:ln w="12700">
+            <a:solidFill>
+              <a:srgbClr val="EA493F"/>
+            </a:solidFill>
+          </a:ln>
+          <a:effectLst/>
+        </p:spPr>
+        <p:style>
+          <a:lnRef idx="1">
+            <a:schemeClr val="accent1"/>
+          </a:lnRef>
+          <a:fillRef idx="3">
+            <a:schemeClr val="accent1"/>
+          </a:fillRef>
+          <a:effectRef idx="2">
+            <a:schemeClr val="accent1"/>
+          </a:effectRef>
+          <a:fontRef idx="minor">
+            <a:schemeClr val="lt1"/>
+          </a:fontRef>
+        </p:style>
+        <p:txBody>
+          <a:bodyPr rtlCol="0" anchor="ctr" lIns="0" rIns="0"/>
+          <a:lstStyle/>
+          <a:p>
+            <a:pPr algn="ctr"/>
+          </a:p>
+        </p:txBody>
+      </p:sp>
+      <p:sp>
+        <p:nvSpPr>
+          <p:cNvPr id="14" name="TextBox 13"/>
+          <p:cNvSpPr txBox="1"/>
+          <p:nvPr/>
+        </p:nvSpPr>
+        <p:spPr>
+          <a:xfrm>
+            <a:off x="1170432" y="3822191"/>
+            <a:ext cx="1335023" cy="566928"/>
+          </a:xfrm>
+          <a:prstGeom prst="rect">
+            <a:avLst/>
+          </a:prstGeom>
+          <a:noFill/>
+        </p:spPr>
+        <p:txBody>
+          <a:bodyPr wrap="square" lIns="0" rIns="0" tIns="0" bIns="0" anchor="ctr">
+            <a:spAutoFit/>
+          </a:bodyPr>
+          <a:lstStyle/>
+          <a:p>
+            <a:pPr algn="ctr">
+              <a:lnSpc>
+                <a:spcPct val="95000"/>
+              </a:lnSpc>
+            </a:pPr>
+            <a:r>
+              <a:rPr sz="950" b="1">
+                <a:solidFill>
+                  <a:srgbClr val="111111"/>
+                </a:solidFill>
+                <a:latin typeface="Inter"/>
+              </a:rPr>
+              <a:t>Engagement Manager</a:t>
+            </a:r>
+          </a:p>
+        </p:txBody>
+      </p:sp>
+      <p:cxnSp>
+        <p:nvCxnSpPr>
+          <p:cNvPr id="15" name="Connector 14"/>
+          <p:cNvCxnSpPr/>
+          <p:nvPr/>
+        </p:nvCxnSpPr>
+        <p:spPr>
+          <a:xfrm>
+            <a:off x="3392423" y="3474720"/>
+            <a:ext cx="0" cy="347471"/>
+          </a:xfrm>
+          <a:prstGeom prst="line">
+            <a:avLst/>
+          </a:prstGeom>
+          <a:ln w="12700">
+            <a:solidFill>
+              <a:srgbClr val="AEAEAE"/>
+            </a:solidFill>
+          </a:ln>
+          <a:effectLst/>
+        </p:spPr>
+        <p:style>
+          <a:lnRef idx="2">
+            <a:schemeClr val="accent1"/>
+          </a:lnRef>
+          <a:fillRef idx="0">
+            <a:schemeClr val="accent1"/>
+          </a:fillRef>
+          <a:effectRef idx="1">
+            <a:schemeClr val="accent1"/>
+          </a:effectRef>
+          <a:fontRef idx="minor">
+            <a:schemeClr val="tx1"/>
+          </a:fontRef>
+        </p:style>
+      </p:cxnSp>
+      <p:sp>
+        <p:nvSpPr>
+          <p:cNvPr id="16" name="Rectangle 15"/>
+          <p:cNvSpPr/>
+          <p:nvPr/>
+        </p:nvSpPr>
+        <p:spPr>
+          <a:xfrm>
+            <a:off x="2688335" y="3822191"/>
+            <a:ext cx="1408175" cy="566928"/>
+          </a:xfrm>
+          <a:prstGeom prst="rect">
+            <a:avLst/>
+          </a:prstGeom>
+          <a:solidFill>
+            <a:srgbClr val="FFFFFF"/>
+          </a:solidFill>
+          <a:ln w="12700">
+            <a:solidFill>
+              <a:srgbClr val="EA493F"/>
+            </a:solidFill>
+          </a:ln>
+          <a:effectLst/>
+        </p:spPr>
+        <p:style>
+          <a:lnRef idx="1">
+            <a:schemeClr val="accent1"/>
+          </a:lnRef>
+          <a:fillRef idx="3">
+            <a:schemeClr val="accent1"/>
+          </a:fillRef>
+          <a:effectRef idx="2">
+            <a:schemeClr val="accent1"/>
+          </a:effectRef>
+          <a:fontRef idx="minor">
+            <a:schemeClr val="lt1"/>
+          </a:fontRef>
+        </p:style>
+        <p:txBody>
+          <a:bodyPr rtlCol="0" anchor="ctr" lIns="0" rIns="0"/>
+          <a:lstStyle/>
+          <a:p>
+            <a:pPr algn="ctr"/>
+          </a:p>
+        </p:txBody>
+      </p:sp>
+      <p:sp>
+        <p:nvSpPr>
+          <p:cNvPr id="17" name="TextBox 16"/>
+          <p:cNvSpPr txBox="1"/>
+          <p:nvPr/>
+        </p:nvSpPr>
+        <p:spPr>
+          <a:xfrm>
+            <a:off x="2724911" y="3822191"/>
+            <a:ext cx="1335023" cy="566928"/>
+          </a:xfrm>
+          <a:prstGeom prst="rect">
+            <a:avLst/>
+          </a:prstGeom>
+          <a:noFill/>
+        </p:spPr>
+        <p:txBody>
+          <a:bodyPr wrap="square" lIns="0" rIns="0" tIns="0" bIns="0" anchor="ctr">
+            <a:spAutoFit/>
+          </a:bodyPr>
+          <a:lstStyle/>
+          <a:p>
+            <a:pPr algn="ctr">
+              <a:lnSpc>
+                <a:spcPct val="95000"/>
+              </a:lnSpc>
+            </a:pPr>
+            <a:r>
+              <a:rPr sz="950" b="1">
+                <a:solidFill>
+                  <a:srgbClr val="111111"/>
+                </a:solidFill>
+                <a:latin typeface="Inter"/>
+              </a:rPr>
+              <a:t>Solution Architect</a:t>
+            </a:r>
+          </a:p>
+        </p:txBody>
+      </p:sp>
+      <p:cxnSp>
+        <p:nvCxnSpPr>
+          <p:cNvPr id="18" name="Connector 17"/>
+          <p:cNvCxnSpPr/>
+          <p:nvPr/>
+        </p:nvCxnSpPr>
+        <p:spPr>
+          <a:xfrm>
+            <a:off x="4946903" y="3474720"/>
+            <a:ext cx="0" cy="347471"/>
+          </a:xfrm>
+          <a:prstGeom prst="line">
+            <a:avLst/>
+          </a:prstGeom>
+          <a:ln w="12700">
+            <a:solidFill>
+              <a:srgbClr val="AEAEAE"/>
+            </a:solidFill>
+          </a:ln>
+          <a:effectLst/>
+        </p:spPr>
+        <p:style>
+          <a:lnRef idx="2">
+            <a:schemeClr val="accent1"/>
+          </a:lnRef>
+          <a:fillRef idx="0">
+            <a:schemeClr val="accent1"/>
+          </a:fillRef>
+          <a:effectRef idx="1">
+            <a:schemeClr val="accent1"/>
+          </a:effectRef>
+          <a:fontRef idx="minor">
+            <a:schemeClr val="tx1"/>
+          </a:fontRef>
+        </p:style>
+      </p:cxnSp>
+      <p:sp>
+        <p:nvSpPr>
+          <p:cNvPr id="19" name="Rectangle 18"/>
+          <p:cNvSpPr/>
+          <p:nvPr/>
+        </p:nvSpPr>
+        <p:spPr>
+          <a:xfrm>
+            <a:off x="4242816" y="3822191"/>
+            <a:ext cx="1408175" cy="566928"/>
+          </a:xfrm>
+          <a:prstGeom prst="rect">
+            <a:avLst/>
+          </a:prstGeom>
+          <a:solidFill>
+            <a:srgbClr val="FFFFFF"/>
+          </a:solidFill>
+          <a:ln w="12700">
+            <a:solidFill>
+              <a:srgbClr val="EA493F"/>
+            </a:solidFill>
+          </a:ln>
+          <a:effectLst/>
+        </p:spPr>
+        <p:style>
+          <a:lnRef idx="1">
+            <a:schemeClr val="accent1"/>
+          </a:lnRef>
+          <a:fillRef idx="3">
+            <a:schemeClr val="accent1"/>
+          </a:fillRef>
+          <a:effectRef idx="2">
+            <a:schemeClr val="accent1"/>
+          </a:effectRef>
+          <a:fontRef idx="minor">
+            <a:schemeClr val="lt1"/>
+          </a:fontRef>
+        </p:style>
+        <p:txBody>
+          <a:bodyPr rtlCol="0" anchor="ctr" lIns="0" rIns="0"/>
+          <a:lstStyle/>
+          <a:p>
+            <a:pPr algn="ctr"/>
+          </a:p>
+        </p:txBody>
+      </p:sp>
+      <p:sp>
+        <p:nvSpPr>
+          <p:cNvPr id="20" name="TextBox 19"/>
+          <p:cNvSpPr txBox="1"/>
+          <p:nvPr/>
+        </p:nvSpPr>
+        <p:spPr>
+          <a:xfrm>
+            <a:off x="4279392" y="3822191"/>
+            <a:ext cx="1335023" cy="566928"/>
+          </a:xfrm>
+          <a:prstGeom prst="rect">
+            <a:avLst/>
+          </a:prstGeom>
+          <a:noFill/>
+        </p:spPr>
+        <p:txBody>
+          <a:bodyPr wrap="square" lIns="0" rIns="0" tIns="0" bIns="0" anchor="ctr">
+            <a:spAutoFit/>
+          </a:bodyPr>
+          <a:lstStyle/>
+          <a:p>
+            <a:pPr algn="ctr">
+              <a:lnSpc>
+                <a:spcPct val="95000"/>
+              </a:lnSpc>
+            </a:pPr>
+            <a:r>
+              <a:rPr sz="950" b="1">
+                <a:solidFill>
+                  <a:srgbClr val="111111"/>
+                </a:solidFill>
+                <a:latin typeface="Inter"/>
+              </a:rPr>
+              <a:t>Data &amp; Integration</a:t>
+            </a:r>
+          </a:p>
+        </p:txBody>
+      </p:sp>
+      <p:sp>
+        <p:nvSpPr>
+          <p:cNvPr id="21" name="Rectangle 20"/>
+          <p:cNvSpPr/>
+          <p:nvPr/>
+        </p:nvSpPr>
+        <p:spPr>
+          <a:xfrm>
+            <a:off x="6291072" y="2194560"/>
+            <a:ext cx="5029200" cy="2395728"/>
+          </a:xfrm>
+          <a:prstGeom prst="rect">
+            <a:avLst/>
+          </a:prstGeom>
+          <a:solidFill>
+            <a:srgbClr val="FFFFFF"/>
+          </a:solidFill>
+          <a:ln w="12700">
+            <a:solidFill>
+              <a:srgbClr val="E4E4E0"/>
+            </a:solidFill>
+          </a:ln>
+          <a:effectLst/>
+        </p:spPr>
+        <p:style>
+          <a:lnRef idx="1">
+            <a:schemeClr val="accent1"/>
+          </a:lnRef>
+          <a:fillRef idx="3">
+            <a:schemeClr val="accent1"/>
+          </a:fillRef>
+          <a:effectRef idx="2">
+            <a:schemeClr val="accent1"/>
+          </a:effectRef>
+          <a:fontRef idx="minor">
+            <a:schemeClr val="lt1"/>
+          </a:fontRef>
+        </p:style>
+        <p:txBody>
+          <a:bodyPr rtlCol="0" anchor="ctr" lIns="0" rIns="0"/>
+          <a:lstStyle/>
+          <a:p>
+            <a:pPr algn="ctr"/>
+          </a:p>
+        </p:txBody>
+      </p:sp>
+      <p:sp>
+        <p:nvSpPr>
+          <p:cNvPr id="22" name="TextBox 21"/>
+          <p:cNvSpPr txBox="1"/>
+          <p:nvPr/>
+        </p:nvSpPr>
+        <p:spPr>
+          <a:xfrm>
+            <a:off x="6565392" y="2377440"/>
+            <a:ext cx="4480560" cy="256032"/>
+          </a:xfrm>
+          <a:prstGeom prst="rect">
+            <a:avLst/>
+          </a:prstGeom>
+          <a:noFill/>
+        </p:spPr>
+        <p:txBody>
+          <a:bodyPr wrap="square" lIns="0" rIns="0" tIns="0" bIns="0" anchor="t">
+            <a:spAutoFit/>
+          </a:bodyPr>
+          <a:lstStyle/>
+          <a:p>
+            <a:pPr algn="ctr"/>
+            <a:r>
+              <a:rPr sz="950" b="1">
+                <a:solidFill>
+                  <a:srgbClr val="111111"/>
+                </a:solidFill>
+                <a:latin typeface="Inter"/>
+              </a:rPr>
+              <a:t>CUSTOMER TEAM</a:t>
+            </a:r>
+          </a:p>
+        </p:txBody>
+      </p:sp>
+      <p:sp>
+        <p:nvSpPr>
+          <p:cNvPr id="23" name="Rectangle 22"/>
+          <p:cNvSpPr/>
+          <p:nvPr/>
+        </p:nvSpPr>
+        <p:spPr>
+          <a:xfrm>
+            <a:off x="7662671" y="2761488"/>
+            <a:ext cx="2286000" cy="457200"/>
+          </a:xfrm>
+          <a:prstGeom prst="rect">
+            <a:avLst/>
+          </a:prstGeom>
+          <a:solidFill>
+            <a:srgbClr val="111111"/>
+          </a:solidFill>
+          <a:ln>
+            <a:noFill/>
+          </a:ln>
+          <a:effectLst/>
+        </p:spPr>
+        <p:style>
+          <a:lnRef idx="1">
+            <a:schemeClr val="accent1"/>
+          </a:lnRef>
+          <a:fillRef idx="3">
+            <a:schemeClr val="accent1"/>
+          </a:fillRef>
+          <a:effectRef idx="2">
+            <a:schemeClr val="accent1"/>
+          </a:effectRef>
+          <a:fontRef idx="minor">
+            <a:schemeClr val="lt1"/>
+          </a:fontRef>
+        </p:style>
+        <p:txBody>
+          <a:bodyPr rtlCol="0" anchor="ctr" lIns="0" rIns="0"/>
+          <a:lstStyle/>
+          <a:p>
+            <a:pPr algn="ctr"/>
+          </a:p>
+        </p:txBody>
+      </p:sp>
+      <p:sp>
+        <p:nvSpPr>
+          <p:cNvPr id="24" name="TextBox 23"/>
+          <p:cNvSpPr txBox="1"/>
+          <p:nvPr/>
+        </p:nvSpPr>
+        <p:spPr>
+          <a:xfrm>
+            <a:off x="7662671" y="2761488"/>
+            <a:ext cx="2286000" cy="457200"/>
+          </a:xfrm>
+          <a:prstGeom prst="rect">
+            <a:avLst/>
+          </a:prstGeom>
+          <a:noFill/>
+        </p:spPr>
+        <p:txBody>
+          <a:bodyPr wrap="square" lIns="0" rIns="0" tIns="0" bIns="0" anchor="ctr">
+            <a:spAutoFit/>
+          </a:bodyPr>
+          <a:lstStyle/>
+          <a:p>
+            <a:pPr algn="ctr"/>
+            <a:r>
+              <a:rPr sz="1200" b="1">
+                <a:solidFill>
+                  <a:srgbClr val="FFFFFF"/>
+                </a:solidFill>
+                <a:latin typeface="Inter"/>
+              </a:rPr>
+              <a:t>Executive Sponsor</a:t>
+            </a:r>
+          </a:p>
+        </p:txBody>
+      </p:sp>
+      <p:cxnSp>
+        <p:nvCxnSpPr>
+          <p:cNvPr id="25" name="Connector 24"/>
+          <p:cNvCxnSpPr/>
+          <p:nvPr/>
+        </p:nvCxnSpPr>
+        <p:spPr>
+          <a:xfrm>
+            <a:off x="8805672" y="3218688"/>
+            <a:ext cx="0" cy="256032"/>
+          </a:xfrm>
+          <a:prstGeom prst="line">
+            <a:avLst/>
+          </a:prstGeom>
+          <a:ln w="12700">
+            <a:solidFill>
+              <a:srgbClr val="AEAEAE"/>
+            </a:solidFill>
+          </a:ln>
+          <a:effectLst/>
+        </p:spPr>
+        <p:style>
+          <a:lnRef idx="2">
+            <a:schemeClr val="accent1"/>
+          </a:lnRef>
+          <a:fillRef idx="0">
+            <a:schemeClr val="accent1"/>
+          </a:fillRef>
+          <a:effectRef idx="1">
+            <a:schemeClr val="accent1"/>
+          </a:effectRef>
+          <a:fontRef idx="minor">
+            <a:schemeClr val="tx1"/>
+          </a:fontRef>
+        </p:style>
+      </p:cxnSp>
+      <p:cxnSp>
+        <p:nvCxnSpPr>
+          <p:cNvPr id="26" name="Connector 25"/>
+          <p:cNvCxnSpPr/>
+          <p:nvPr/>
+        </p:nvCxnSpPr>
+        <p:spPr>
+          <a:xfrm>
+            <a:off x="6951268" y="3474720"/>
+            <a:ext cx="3708807" cy="0"/>
+          </a:xfrm>
+          <a:prstGeom prst="line">
+            <a:avLst/>
+          </a:prstGeom>
+          <a:ln w="12700">
+            <a:solidFill>
+              <a:srgbClr val="AEAEAE"/>
+            </a:solidFill>
+          </a:ln>
+          <a:effectLst/>
+        </p:spPr>
+        <p:style>
+          <a:lnRef idx="2">
+            <a:schemeClr val="accent1"/>
+          </a:lnRef>
+          <a:fillRef idx="0">
+            <a:schemeClr val="accent1"/>
+          </a:fillRef>
+          <a:effectRef idx="1">
+            <a:schemeClr val="accent1"/>
+          </a:effectRef>
+          <a:fontRef idx="minor">
+            <a:schemeClr val="tx1"/>
+          </a:fontRef>
+        </p:style>
+      </p:cxnSp>
+      <p:cxnSp>
+        <p:nvCxnSpPr>
+          <p:cNvPr id="27" name="Connector 26"/>
+          <p:cNvCxnSpPr/>
+          <p:nvPr/>
+        </p:nvCxnSpPr>
+        <p:spPr>
+          <a:xfrm>
+            <a:off x="6951268" y="3474720"/>
+            <a:ext cx="0" cy="347471"/>
+          </a:xfrm>
+          <a:prstGeom prst="line">
+            <a:avLst/>
+          </a:prstGeom>
+          <a:ln w="12700">
+            <a:solidFill>
+              <a:srgbClr val="AEAEAE"/>
+            </a:solidFill>
+          </a:ln>
+          <a:effectLst/>
+        </p:spPr>
+        <p:style>
+          <a:lnRef idx="2">
+            <a:schemeClr val="accent1"/>
+          </a:lnRef>
+          <a:fillRef idx="0">
+            <a:schemeClr val="accent1"/>
+          </a:fillRef>
+          <a:effectRef idx="1">
+            <a:schemeClr val="accent1"/>
+          </a:effectRef>
+          <a:fontRef idx="minor">
+            <a:schemeClr val="tx1"/>
+          </a:fontRef>
+        </p:style>
+      </p:cxnSp>
+      <p:sp>
+        <p:nvSpPr>
+          <p:cNvPr id="28" name="Rectangle 27"/>
+          <p:cNvSpPr/>
+          <p:nvPr/>
+        </p:nvSpPr>
+        <p:spPr>
+          <a:xfrm>
+            <a:off x="6547104" y="3822191"/>
+            <a:ext cx="808329" cy="566928"/>
+          </a:xfrm>
+          <a:prstGeom prst="rect">
+            <a:avLst/>
+          </a:prstGeom>
+          <a:solidFill>
+            <a:srgbClr val="FFFFFF"/>
+          </a:solidFill>
+          <a:ln w="12700">
+            <a:solidFill>
+              <a:srgbClr val="C9C9C4"/>
+            </a:solidFill>
+          </a:ln>
+          <a:effectLst/>
+        </p:spPr>
+        <p:style>
+          <a:lnRef idx="1">
+            <a:schemeClr val="accent1"/>
+          </a:lnRef>
+          <a:fillRef idx="3">
+            <a:schemeClr val="accent1"/>
+          </a:fillRef>
+          <a:effectRef idx="2">
+            <a:schemeClr val="accent1"/>
+          </a:effectRef>
+          <a:fontRef idx="minor">
+            <a:schemeClr val="lt1"/>
+          </a:fontRef>
+        </p:style>
+        <p:txBody>
+          <a:bodyPr rtlCol="0" anchor="ctr" lIns="0" rIns="0"/>
+          <a:lstStyle/>
+          <a:p>
+            <a:pPr algn="ctr"/>
+          </a:p>
+        </p:txBody>
+      </p:sp>
+      <p:sp>
+        <p:nvSpPr>
+          <p:cNvPr id="29" name="TextBox 28"/>
+          <p:cNvSpPr txBox="1"/>
+          <p:nvPr/>
+        </p:nvSpPr>
+        <p:spPr>
+          <a:xfrm>
+            <a:off x="6583680" y="3822191"/>
+            <a:ext cx="735177" cy="566928"/>
+          </a:xfrm>
+          <a:prstGeom prst="rect">
+            <a:avLst/>
+          </a:prstGeom>
+          <a:noFill/>
+        </p:spPr>
+        <p:txBody>
+          <a:bodyPr wrap="square" lIns="0" rIns="0" tIns="0" bIns="0" anchor="ctr">
+            <a:spAutoFit/>
+          </a:bodyPr>
+          <a:lstStyle/>
+          <a:p>
+            <a:pPr algn="ctr">
+              <a:lnSpc>
+                <a:spcPct val="95000"/>
+              </a:lnSpc>
+            </a:pPr>
+            <a:r>
+              <a:rPr sz="850" b="1">
+                <a:solidFill>
+                  <a:srgbClr val="111111"/>
+                </a:solidFill>
+                <a:latin typeface="Inter"/>
+              </a:rPr>
+              <a:t>Project Manager</a:t>
+            </a:r>
+          </a:p>
+        </p:txBody>
+      </p:sp>
+      <p:cxnSp>
+        <p:nvCxnSpPr>
+          <p:cNvPr id="30" name="Connector 29"/>
+          <p:cNvCxnSpPr/>
+          <p:nvPr/>
+        </p:nvCxnSpPr>
+        <p:spPr>
+          <a:xfrm>
+            <a:off x="7878470" y="3474720"/>
+            <a:ext cx="0" cy="347471"/>
+          </a:xfrm>
+          <a:prstGeom prst="line">
+            <a:avLst/>
+          </a:prstGeom>
+          <a:ln w="12700">
+            <a:solidFill>
+              <a:srgbClr val="AEAEAE"/>
+            </a:solidFill>
+          </a:ln>
+          <a:effectLst/>
+        </p:spPr>
+        <p:style>
+          <a:lnRef idx="2">
+            <a:schemeClr val="accent1"/>
+          </a:lnRef>
+          <a:fillRef idx="0">
+            <a:schemeClr val="accent1"/>
+          </a:fillRef>
+          <a:effectRef idx="1">
+            <a:schemeClr val="accent1"/>
+          </a:effectRef>
+          <a:fontRef idx="minor">
+            <a:schemeClr val="tx1"/>
+          </a:fontRef>
+        </p:style>
+      </p:cxnSp>
+      <p:sp>
+        <p:nvSpPr>
+          <p:cNvPr id="31" name="Rectangle 30"/>
+          <p:cNvSpPr/>
+          <p:nvPr/>
+        </p:nvSpPr>
+        <p:spPr>
+          <a:xfrm>
+            <a:off x="7474305" y="3822191"/>
+            <a:ext cx="808329" cy="566928"/>
+          </a:xfrm>
+          <a:prstGeom prst="rect">
+            <a:avLst/>
+          </a:prstGeom>
+          <a:solidFill>
+            <a:srgbClr val="FFFFFF"/>
+          </a:solidFill>
+          <a:ln w="12700">
+            <a:solidFill>
+              <a:srgbClr val="C9C9C4"/>
+            </a:solidFill>
+          </a:ln>
+          <a:effectLst/>
+        </p:spPr>
+        <p:style>
+          <a:lnRef idx="1">
+            <a:schemeClr val="accent1"/>
+          </a:lnRef>
+          <a:fillRef idx="3">
+            <a:schemeClr val="accent1"/>
+          </a:fillRef>
+          <a:effectRef idx="2">
+            <a:schemeClr val="accent1"/>
+          </a:effectRef>
+          <a:fontRef idx="minor">
+            <a:schemeClr val="lt1"/>
+          </a:fontRef>
+        </p:style>
+        <p:txBody>
+          <a:bodyPr rtlCol="0" anchor="ctr" lIns="0" rIns="0"/>
+          <a:lstStyle/>
+          <a:p>
+            <a:pPr algn="ctr"/>
+          </a:p>
+        </p:txBody>
+      </p:sp>
+      <p:sp>
+        <p:nvSpPr>
+          <p:cNvPr id="32" name="TextBox 31"/>
+          <p:cNvSpPr txBox="1"/>
+          <p:nvPr/>
+        </p:nvSpPr>
+        <p:spPr>
+          <a:xfrm>
+            <a:off x="7510881" y="3822191"/>
+            <a:ext cx="735177" cy="566928"/>
+          </a:xfrm>
+          <a:prstGeom prst="rect">
+            <a:avLst/>
+          </a:prstGeom>
+          <a:noFill/>
+        </p:spPr>
+        <p:txBody>
+          <a:bodyPr wrap="square" lIns="0" rIns="0" tIns="0" bIns="0" anchor="ctr">
+            <a:spAutoFit/>
+          </a:bodyPr>
+          <a:lstStyle/>
+          <a:p>
+            <a:pPr algn="ctr">
+              <a:lnSpc>
+                <a:spcPct val="95000"/>
+              </a:lnSpc>
+            </a:pPr>
+            <a:r>
+              <a:rPr sz="850" b="1">
+                <a:solidFill>
+                  <a:srgbClr val="111111"/>
+                </a:solidFill>
+                <a:latin typeface="Inter"/>
+              </a:rPr>
+              <a:t>Change Manager</a:t>
+            </a:r>
+          </a:p>
+        </p:txBody>
+      </p:sp>
+      <p:cxnSp>
+        <p:nvCxnSpPr>
+          <p:cNvPr id="33" name="Connector 32"/>
+          <p:cNvCxnSpPr/>
+          <p:nvPr/>
+        </p:nvCxnSpPr>
+        <p:spPr>
+          <a:xfrm>
+            <a:off x="8805672" y="3474720"/>
+            <a:ext cx="0" cy="347471"/>
+          </a:xfrm>
+          <a:prstGeom prst="line">
+            <a:avLst/>
+          </a:prstGeom>
+          <a:ln w="12700">
+            <a:solidFill>
+              <a:srgbClr val="AEAEAE"/>
+            </a:solidFill>
+          </a:ln>
+          <a:effectLst/>
+        </p:spPr>
+        <p:style>
+          <a:lnRef idx="2">
+            <a:schemeClr val="accent1"/>
+          </a:lnRef>
+          <a:fillRef idx="0">
+            <a:schemeClr val="accent1"/>
+          </a:fillRef>
+          <a:effectRef idx="1">
+            <a:schemeClr val="accent1"/>
+          </a:effectRef>
+          <a:fontRef idx="minor">
+            <a:schemeClr val="tx1"/>
+          </a:fontRef>
+        </p:style>
+      </p:cxnSp>
+      <p:sp>
+        <p:nvSpPr>
+          <p:cNvPr id="34" name="Rectangle 33"/>
+          <p:cNvSpPr/>
+          <p:nvPr/>
+        </p:nvSpPr>
+        <p:spPr>
+          <a:xfrm>
+            <a:off x="8401507" y="3822191"/>
+            <a:ext cx="808329" cy="566928"/>
+          </a:xfrm>
+          <a:prstGeom prst="rect">
+            <a:avLst/>
+          </a:prstGeom>
+          <a:solidFill>
+            <a:srgbClr val="FFFFFF"/>
+          </a:solidFill>
+          <a:ln w="12700">
+            <a:solidFill>
+              <a:srgbClr val="C9C9C4"/>
+            </a:solidFill>
+          </a:ln>
+          <a:effectLst/>
+        </p:spPr>
+        <p:style>
+          <a:lnRef idx="1">
+            <a:schemeClr val="accent1"/>
+          </a:lnRef>
+          <a:fillRef idx="3">
+            <a:schemeClr val="accent1"/>
+          </a:fillRef>
+          <a:effectRef idx="2">
+            <a:schemeClr val="accent1"/>
+          </a:effectRef>
+          <a:fontRef idx="minor">
+            <a:schemeClr val="lt1"/>
+          </a:fontRef>
+        </p:style>
+        <p:txBody>
+          <a:bodyPr rtlCol="0" anchor="ctr" lIns="0" rIns="0"/>
+          <a:lstStyle/>
+          <a:p>
+            <a:pPr algn="ctr"/>
+          </a:p>
+        </p:txBody>
+      </p:sp>
+      <p:sp>
+        <p:nvSpPr>
+          <p:cNvPr id="35" name="TextBox 34"/>
+          <p:cNvSpPr txBox="1"/>
+          <p:nvPr/>
+        </p:nvSpPr>
+        <p:spPr>
+          <a:xfrm>
+            <a:off x="8438083" y="3822191"/>
+            <a:ext cx="735177" cy="566928"/>
+          </a:xfrm>
+          <a:prstGeom prst="rect">
+            <a:avLst/>
+          </a:prstGeom>
+          <a:noFill/>
+        </p:spPr>
+        <p:txBody>
+          <a:bodyPr wrap="square" lIns="0" rIns="0" tIns="0" bIns="0" anchor="ctr">
+            <a:spAutoFit/>
+          </a:bodyPr>
+          <a:lstStyle/>
+          <a:p>
+            <a:pPr algn="ctr">
+              <a:lnSpc>
+                <a:spcPct val="95000"/>
+              </a:lnSpc>
+            </a:pPr>
+            <a:r>
+              <a:rPr sz="850" b="1">
+                <a:solidFill>
+                  <a:srgbClr val="111111"/>
+                </a:solidFill>
+                <a:latin typeface="Inter"/>
+              </a:rPr>
+              <a:t>Functional Leads</a:t>
+            </a:r>
+          </a:p>
+        </p:txBody>
+      </p:sp>
+      <p:cxnSp>
+        <p:nvCxnSpPr>
+          <p:cNvPr id="36" name="Connector 35"/>
+          <p:cNvCxnSpPr/>
+          <p:nvPr/>
+        </p:nvCxnSpPr>
+        <p:spPr>
+          <a:xfrm>
+            <a:off x="9732873" y="3474720"/>
+            <a:ext cx="0" cy="347471"/>
+          </a:xfrm>
+          <a:prstGeom prst="line">
+            <a:avLst/>
+          </a:prstGeom>
+          <a:ln w="12700">
+            <a:solidFill>
+              <a:srgbClr val="AEAEAE"/>
+            </a:solidFill>
+          </a:ln>
+          <a:effectLst/>
+        </p:spPr>
+        <p:style>
+          <a:lnRef idx="2">
+            <a:schemeClr val="accent1"/>
+          </a:lnRef>
+          <a:fillRef idx="0">
+            <a:schemeClr val="accent1"/>
+          </a:fillRef>
+          <a:effectRef idx="1">
+            <a:schemeClr val="accent1"/>
+          </a:effectRef>
+          <a:fontRef idx="minor">
+            <a:schemeClr val="tx1"/>
+          </a:fontRef>
+        </p:style>
+      </p:cxnSp>
+      <p:sp>
+        <p:nvSpPr>
+          <p:cNvPr id="37" name="Rectangle 36"/>
+          <p:cNvSpPr/>
+          <p:nvPr/>
+        </p:nvSpPr>
+        <p:spPr>
+          <a:xfrm>
+            <a:off x="9328708" y="3822191"/>
+            <a:ext cx="808329" cy="566928"/>
+          </a:xfrm>
+          <a:prstGeom prst="rect">
+            <a:avLst/>
+          </a:prstGeom>
+          <a:solidFill>
+            <a:srgbClr val="FFFFFF"/>
+          </a:solidFill>
+          <a:ln w="12700">
+            <a:solidFill>
+              <a:srgbClr val="C9C9C4"/>
+            </a:solidFill>
+          </a:ln>
+          <a:effectLst/>
+        </p:spPr>
+        <p:style>
+          <a:lnRef idx="1">
+            <a:schemeClr val="accent1"/>
+          </a:lnRef>
+          <a:fillRef idx="3">
+            <a:schemeClr val="accent1"/>
+          </a:fillRef>
+          <a:effectRef idx="2">
+            <a:schemeClr val="accent1"/>
+          </a:effectRef>
+          <a:fontRef idx="minor">
+            <a:schemeClr val="lt1"/>
+          </a:fontRef>
+        </p:style>
+        <p:txBody>
+          <a:bodyPr rtlCol="0" anchor="ctr" lIns="0" rIns="0"/>
+          <a:lstStyle/>
+          <a:p>
+            <a:pPr algn="ctr"/>
+          </a:p>
+        </p:txBody>
+      </p:sp>
+      <p:sp>
+        <p:nvSpPr>
+          <p:cNvPr id="38" name="TextBox 37"/>
+          <p:cNvSpPr txBox="1"/>
+          <p:nvPr/>
+        </p:nvSpPr>
+        <p:spPr>
+          <a:xfrm>
+            <a:off x="9365284" y="3822191"/>
+            <a:ext cx="735177" cy="566928"/>
+          </a:xfrm>
+          <a:prstGeom prst="rect">
+            <a:avLst/>
+          </a:prstGeom>
+          <a:noFill/>
+        </p:spPr>
+        <p:txBody>
+          <a:bodyPr wrap="square" lIns="0" rIns="0" tIns="0" bIns="0" anchor="ctr">
+            <a:spAutoFit/>
+          </a:bodyPr>
+          <a:lstStyle/>
+          <a:p>
+            <a:pPr algn="ctr">
+              <a:lnSpc>
+                <a:spcPct val="95000"/>
+              </a:lnSpc>
+            </a:pPr>
+            <a:r>
+              <a:rPr sz="850" b="1">
+                <a:solidFill>
+                  <a:srgbClr val="111111"/>
+                </a:solidFill>
+                <a:latin typeface="Inter"/>
+              </a:rPr>
+              <a:t>Testing Lead</a:t>
+            </a:r>
+          </a:p>
+        </p:txBody>
+      </p:sp>
+      <p:cxnSp>
+        <p:nvCxnSpPr>
+          <p:cNvPr id="39" name="Connector 38"/>
+          <p:cNvCxnSpPr/>
+          <p:nvPr/>
+        </p:nvCxnSpPr>
+        <p:spPr>
+          <a:xfrm>
+            <a:off x="10660075" y="3474720"/>
+            <a:ext cx="0" cy="347471"/>
+          </a:xfrm>
+          <a:prstGeom prst="line">
+            <a:avLst/>
+          </a:prstGeom>
+          <a:ln w="12700">
+            <a:solidFill>
+              <a:srgbClr val="AEAEAE"/>
+            </a:solidFill>
+          </a:ln>
+          <a:effectLst/>
+        </p:spPr>
+        <p:style>
+          <a:lnRef idx="2">
+            <a:schemeClr val="accent1"/>
+          </a:lnRef>
+          <a:fillRef idx="0">
+            <a:schemeClr val="accent1"/>
+          </a:fillRef>
+          <a:effectRef idx="1">
+            <a:schemeClr val="accent1"/>
+          </a:effectRef>
+          <a:fontRef idx="minor">
+            <a:schemeClr val="tx1"/>
+          </a:fontRef>
+        </p:style>
+      </p:cxnSp>
+      <p:sp>
+        <p:nvSpPr>
+          <p:cNvPr id="40" name="Rectangle 39"/>
+          <p:cNvSpPr/>
+          <p:nvPr/>
+        </p:nvSpPr>
+        <p:spPr>
+          <a:xfrm>
+            <a:off x="10255910" y="3822191"/>
+            <a:ext cx="808329" cy="566928"/>
+          </a:xfrm>
+          <a:prstGeom prst="rect">
+            <a:avLst/>
+          </a:prstGeom>
+          <a:solidFill>
+            <a:srgbClr val="FFFFFF"/>
+          </a:solidFill>
+          <a:ln w="12700">
+            <a:solidFill>
+              <a:srgbClr val="C9C9C4"/>
+            </a:solidFill>
+          </a:ln>
+          <a:effectLst/>
+        </p:spPr>
+        <p:style>
+          <a:lnRef idx="1">
+            <a:schemeClr val="accent1"/>
+          </a:lnRef>
+          <a:fillRef idx="3">
+            <a:schemeClr val="accent1"/>
+          </a:fillRef>
+          <a:effectRef idx="2">
+            <a:schemeClr val="accent1"/>
+          </a:effectRef>
+          <a:fontRef idx="minor">
+            <a:schemeClr val="lt1"/>
+          </a:fontRef>
+        </p:style>
+        <p:txBody>
+          <a:bodyPr rtlCol="0" anchor="ctr" lIns="0" rIns="0"/>
+          <a:lstStyle/>
+          <a:p>
+            <a:pPr algn="ctr"/>
+          </a:p>
+        </p:txBody>
+      </p:sp>
+      <p:sp>
+        <p:nvSpPr>
+          <p:cNvPr id="41" name="TextBox 40"/>
+          <p:cNvSpPr txBox="1"/>
+          <p:nvPr/>
+        </p:nvSpPr>
+        <p:spPr>
+          <a:xfrm>
+            <a:off x="10292486" y="3822191"/>
+            <a:ext cx="735177" cy="566928"/>
+          </a:xfrm>
+          <a:prstGeom prst="rect">
+            <a:avLst/>
+          </a:prstGeom>
+          <a:noFill/>
+        </p:spPr>
+        <p:txBody>
+          <a:bodyPr wrap="square" lIns="0" rIns="0" tIns="0" bIns="0" anchor="ctr">
+            <a:spAutoFit/>
+          </a:bodyPr>
+          <a:lstStyle/>
+          <a:p>
+            <a:pPr algn="ctr">
+              <a:lnSpc>
+                <a:spcPct val="95000"/>
+              </a:lnSpc>
+            </a:pPr>
+            <a:r>
+              <a:rPr sz="850" b="1">
+                <a:solidFill>
+                  <a:srgbClr val="111111"/>
+                </a:solidFill>
+                <a:latin typeface="Inter"/>
+              </a:rPr>
+              <a:t>Data Champions</a:t>
+            </a:r>
+          </a:p>
+        </p:txBody>
+      </p:sp>
+      <p:sp>
+        <p:nvSpPr>
+          <p:cNvPr id="42" name="Rectangle 41"/>
+          <p:cNvSpPr/>
+          <p:nvPr/>
+        </p:nvSpPr>
+        <p:spPr>
+          <a:xfrm>
+            <a:off x="877824" y="4882896"/>
+            <a:ext cx="10442448" cy="1024128"/>
+          </a:xfrm>
+          <a:prstGeom prst="rect">
+            <a:avLst/>
+          </a:prstGeom>
+          <a:solidFill>
+            <a:srgbClr val="111111"/>
+          </a:solidFill>
+          <a:ln>
+            <a:noFill/>
+          </a:ln>
+          <a:effectLst/>
+        </p:spPr>
+        <p:style>
+          <a:lnRef idx="1">
+            <a:schemeClr val="accent1"/>
+          </a:lnRef>
+          <a:fillRef idx="3">
+            <a:schemeClr val="accent1"/>
+          </a:fillRef>
+          <a:effectRef idx="2">
+            <a:schemeClr val="accent1"/>
+          </a:effectRef>
+          <a:fontRef idx="minor">
+            <a:schemeClr val="lt1"/>
+          </a:fontRef>
+        </p:style>
+        <p:txBody>
+          <a:bodyPr rtlCol="0" anchor="ctr" lIns="0" rIns="0"/>
+          <a:lstStyle/>
+          <a:p>
+            <a:pPr algn="ctr"/>
+          </a:p>
+        </p:txBody>
+      </p:sp>
+      <p:sp>
+        <p:nvSpPr>
+          <p:cNvPr id="43" name="TextBox 42"/>
+          <p:cNvSpPr txBox="1"/>
+          <p:nvPr/>
+        </p:nvSpPr>
+        <p:spPr>
+          <a:xfrm>
+            <a:off x="1207008" y="4882896"/>
+            <a:ext cx="9784080" cy="1024128"/>
+          </a:xfrm>
+          <a:prstGeom prst="rect">
+            <a:avLst/>
+          </a:prstGeom>
+          <a:noFill/>
+        </p:spPr>
+        <p:txBody>
+          <a:bodyPr wrap="square" lIns="0" rIns="0" tIns="0" bIns="0" anchor="ctr">
+            <a:spAutoFit/>
+          </a:bodyPr>
+          <a:lstStyle/>
+          <a:p>
+            <a:pPr algn="l">
+              <a:lnSpc>
+                <a:spcPct val="118000"/>
+              </a:lnSpc>
+            </a:pPr>
+            <a:r>
+              <a:rPr sz="1150" b="1">
+                <a:solidFill>
+                  <a:srgbClr val="EA493F"/>
+                </a:solidFill>
+                <a:latin typeface="Inter"/>
+              </a:rPr>
+              <a:t>A note on your team — </a:t>
+            </a:r>
+            <a:r>
+              <a:rPr sz="1150" b="0">
+                <a:solidFill>
+                  <a:srgbClr val="FFFFFF"/>
+                </a:solidFill>
+                <a:latin typeface="Inter"/>
+              </a:rPr>
+              <a:t>these roles don't have to be separate individuals. In many organisations the same people play multiple roles; what matters is that every role is owned by someone with the authority and time to fulfil it.</a:t>
             </a:r>
           </a:p>
         </p:txBody>

</xml_diff>

<commit_message>
standard: drop left-accent stripe on cards; use the slide 7/8 box idiom everywhere
The thin coral/ink left-edge stripe (an AI 'tell') is removed from every card
across Velocity, Payroll, Coverage, Coverage model, Commercials and Augmentation
(37 bars). Boxes now match the 'Four ways' / 'Workday lifecycle' standard: a
filled/bordered rectangle with a coral label inside, nothing else. Regenerated
the light/dark decks, HTML, A4 and Word.

https://claude.ai/code/session_013KakfoRwev8fSFVnXRjTeJ
</commit_message>
<xml_diff>
--- a/design-system/standard/Mivada_Standard.pptx
+++ b/design-system/standard/Mivada_Standard.pptx
@@ -7970,50 +7970,6 @@
       </p:sp>
       <p:sp>
         <p:nvSpPr>
-          <p:cNvPr id="7" name="Rectangle 6"/>
-          <p:cNvSpPr/>
-          <p:nvPr/>
-        </p:nvSpPr>
-        <p:spPr>
-          <a:xfrm>
-            <a:off x="877824" y="2212848"/>
-            <a:ext cx="91440" cy="1078992"/>
-          </a:xfrm>
-          <a:prstGeom prst="rect">
-            <a:avLst/>
-          </a:prstGeom>
-          <a:solidFill>
-            <a:srgbClr val="EA493F"/>
-          </a:solidFill>
-          <a:ln>
-            <a:noFill/>
-          </a:ln>
-          <a:effectLst/>
-        </p:spPr>
-        <p:style>
-          <a:lnRef idx="1">
-            <a:schemeClr val="accent1"/>
-          </a:lnRef>
-          <a:fillRef idx="3">
-            <a:schemeClr val="accent1"/>
-          </a:fillRef>
-          <a:effectRef idx="2">
-            <a:schemeClr val="accent1"/>
-          </a:effectRef>
-          <a:fontRef idx="minor">
-            <a:schemeClr val="lt1"/>
-          </a:fontRef>
-        </p:style>
-        <p:txBody>
-          <a:bodyPr rtlCol="0" anchor="ctr" lIns="0" rIns="0"/>
-          <a:lstStyle/>
-          <a:p>
-            <a:pPr algn="ctr"/>
-          </a:p>
-        </p:txBody>
-      </p:sp>
-      <p:sp>
-        <p:nvSpPr>
           <p:cNvPr id="8" name="TextBox 7"/>
           <p:cNvSpPr txBox="1"/>
           <p:nvPr/>
@@ -8169,50 +8125,6 @@
       </p:sp>
       <p:sp>
         <p:nvSpPr>
-          <p:cNvPr id="12" name="Rectangle 11"/>
-          <p:cNvSpPr/>
-          <p:nvPr/>
-        </p:nvSpPr>
-        <p:spPr>
-          <a:xfrm>
-            <a:off x="4480559" y="2212848"/>
-            <a:ext cx="91440" cy="1078992"/>
-          </a:xfrm>
-          <a:prstGeom prst="rect">
-            <a:avLst/>
-          </a:prstGeom>
-          <a:solidFill>
-            <a:srgbClr val="EA493F"/>
-          </a:solidFill>
-          <a:ln>
-            <a:noFill/>
-          </a:ln>
-          <a:effectLst/>
-        </p:spPr>
-        <p:style>
-          <a:lnRef idx="1">
-            <a:schemeClr val="accent1"/>
-          </a:lnRef>
-          <a:fillRef idx="3">
-            <a:schemeClr val="accent1"/>
-          </a:fillRef>
-          <a:effectRef idx="2">
-            <a:schemeClr val="accent1"/>
-          </a:effectRef>
-          <a:fontRef idx="minor">
-            <a:schemeClr val="lt1"/>
-          </a:fontRef>
-        </p:style>
-        <p:txBody>
-          <a:bodyPr rtlCol="0" anchor="ctr" lIns="0" rIns="0"/>
-          <a:lstStyle/>
-          <a:p>
-            <a:pPr algn="ctr"/>
-          </a:p>
-        </p:txBody>
-      </p:sp>
-      <p:sp>
-        <p:nvSpPr>
           <p:cNvPr id="13" name="TextBox 12"/>
           <p:cNvSpPr txBox="1"/>
           <p:nvPr/>
@@ -8341,50 +8253,6 @@
             <a:solidFill>
               <a:srgbClr val="E4E4E0"/>
             </a:solidFill>
-          </a:ln>
-          <a:effectLst/>
-        </p:spPr>
-        <p:style>
-          <a:lnRef idx="1">
-            <a:schemeClr val="accent1"/>
-          </a:lnRef>
-          <a:fillRef idx="3">
-            <a:schemeClr val="accent1"/>
-          </a:fillRef>
-          <a:effectRef idx="2">
-            <a:schemeClr val="accent1"/>
-          </a:effectRef>
-          <a:fontRef idx="minor">
-            <a:schemeClr val="lt1"/>
-          </a:fontRef>
-        </p:style>
-        <p:txBody>
-          <a:bodyPr rtlCol="0" anchor="ctr" lIns="0" rIns="0"/>
-          <a:lstStyle/>
-          <a:p>
-            <a:pPr algn="ctr"/>
-          </a:p>
-        </p:txBody>
-      </p:sp>
-      <p:sp>
-        <p:nvSpPr>
-          <p:cNvPr id="17" name="Rectangle 16"/>
-          <p:cNvSpPr/>
-          <p:nvPr/>
-        </p:nvSpPr>
-        <p:spPr>
-          <a:xfrm>
-            <a:off x="8083296" y="2212848"/>
-            <a:ext cx="91440" cy="1078992"/>
-          </a:xfrm>
-          <a:prstGeom prst="rect">
-            <a:avLst/>
-          </a:prstGeom>
-          <a:solidFill>
-            <a:srgbClr val="EA493F"/>
-          </a:solidFill>
-          <a:ln>
-            <a:noFill/>
           </a:ln>
           <a:effectLst/>
         </p:spPr>
@@ -9622,50 +9490,6 @@
       </p:sp>
       <p:sp>
         <p:nvSpPr>
-          <p:cNvPr id="9" name="Rectangle 8"/>
-          <p:cNvSpPr/>
-          <p:nvPr/>
-        </p:nvSpPr>
-        <p:spPr>
-          <a:xfrm>
-            <a:off x="877824" y="2670048"/>
-            <a:ext cx="54864" cy="420624"/>
-          </a:xfrm>
-          <a:prstGeom prst="rect">
-            <a:avLst/>
-          </a:prstGeom>
-          <a:solidFill>
-            <a:srgbClr val="EA493F"/>
-          </a:solidFill>
-          <a:ln>
-            <a:noFill/>
-          </a:ln>
-          <a:effectLst/>
-        </p:spPr>
-        <p:style>
-          <a:lnRef idx="1">
-            <a:schemeClr val="accent1"/>
-          </a:lnRef>
-          <a:fillRef idx="3">
-            <a:schemeClr val="accent1"/>
-          </a:fillRef>
-          <a:effectRef idx="2">
-            <a:schemeClr val="accent1"/>
-          </a:effectRef>
-          <a:fontRef idx="minor">
-            <a:schemeClr val="lt1"/>
-          </a:fontRef>
-        </p:style>
-        <p:txBody>
-          <a:bodyPr rtlCol="0" anchor="ctr" lIns="0" rIns="0"/>
-          <a:lstStyle/>
-          <a:p>
-            <a:pPr algn="ctr"/>
-          </a:p>
-        </p:txBody>
-      </p:sp>
-      <p:sp>
-        <p:nvSpPr>
           <p:cNvPr id="10" name="TextBox 9"/>
           <p:cNvSpPr txBox="1"/>
           <p:nvPr/>
@@ -9747,50 +9571,6 @@
       </p:sp>
       <p:sp>
         <p:nvSpPr>
-          <p:cNvPr id="12" name="Rectangle 11"/>
-          <p:cNvSpPr/>
-          <p:nvPr/>
-        </p:nvSpPr>
-        <p:spPr>
-          <a:xfrm>
-            <a:off x="3465576" y="2670048"/>
-            <a:ext cx="54864" cy="420624"/>
-          </a:xfrm>
-          <a:prstGeom prst="rect">
-            <a:avLst/>
-          </a:prstGeom>
-          <a:solidFill>
-            <a:srgbClr val="EA493F"/>
-          </a:solidFill>
-          <a:ln>
-            <a:noFill/>
-          </a:ln>
-          <a:effectLst/>
-        </p:spPr>
-        <p:style>
-          <a:lnRef idx="1">
-            <a:schemeClr val="accent1"/>
-          </a:lnRef>
-          <a:fillRef idx="3">
-            <a:schemeClr val="accent1"/>
-          </a:fillRef>
-          <a:effectRef idx="2">
-            <a:schemeClr val="accent1"/>
-          </a:effectRef>
-          <a:fontRef idx="minor">
-            <a:schemeClr val="lt1"/>
-          </a:fontRef>
-        </p:style>
-        <p:txBody>
-          <a:bodyPr rtlCol="0" anchor="ctr" lIns="0" rIns="0"/>
-          <a:lstStyle/>
-          <a:p>
-            <a:pPr algn="ctr"/>
-          </a:p>
-        </p:txBody>
-      </p:sp>
-      <p:sp>
-        <p:nvSpPr>
           <p:cNvPr id="13" name="TextBox 12"/>
           <p:cNvSpPr txBox="1"/>
           <p:nvPr/>
@@ -9872,50 +9652,6 @@
       </p:sp>
       <p:sp>
         <p:nvSpPr>
-          <p:cNvPr id="15" name="Rectangle 14"/>
-          <p:cNvSpPr/>
-          <p:nvPr/>
-        </p:nvSpPr>
-        <p:spPr>
-          <a:xfrm>
-            <a:off x="877824" y="3168396"/>
-            <a:ext cx="54864" cy="420624"/>
-          </a:xfrm>
-          <a:prstGeom prst="rect">
-            <a:avLst/>
-          </a:prstGeom>
-          <a:solidFill>
-            <a:srgbClr val="EA493F"/>
-          </a:solidFill>
-          <a:ln>
-            <a:noFill/>
-          </a:ln>
-          <a:effectLst/>
-        </p:spPr>
-        <p:style>
-          <a:lnRef idx="1">
-            <a:schemeClr val="accent1"/>
-          </a:lnRef>
-          <a:fillRef idx="3">
-            <a:schemeClr val="accent1"/>
-          </a:fillRef>
-          <a:effectRef idx="2">
-            <a:schemeClr val="accent1"/>
-          </a:effectRef>
-          <a:fontRef idx="minor">
-            <a:schemeClr val="lt1"/>
-          </a:fontRef>
-        </p:style>
-        <p:txBody>
-          <a:bodyPr rtlCol="0" anchor="ctr" lIns="0" rIns="0"/>
-          <a:lstStyle/>
-          <a:p>
-            <a:pPr algn="ctr"/>
-          </a:p>
-        </p:txBody>
-      </p:sp>
-      <p:sp>
-        <p:nvSpPr>
           <p:cNvPr id="16" name="TextBox 15"/>
           <p:cNvSpPr txBox="1"/>
           <p:nvPr/>
@@ -9997,50 +9733,6 @@
       </p:sp>
       <p:sp>
         <p:nvSpPr>
-          <p:cNvPr id="18" name="Rectangle 17"/>
-          <p:cNvSpPr/>
-          <p:nvPr/>
-        </p:nvSpPr>
-        <p:spPr>
-          <a:xfrm>
-            <a:off x="3465576" y="3168396"/>
-            <a:ext cx="54864" cy="420624"/>
-          </a:xfrm>
-          <a:prstGeom prst="rect">
-            <a:avLst/>
-          </a:prstGeom>
-          <a:solidFill>
-            <a:srgbClr val="EA493F"/>
-          </a:solidFill>
-          <a:ln>
-            <a:noFill/>
-          </a:ln>
-          <a:effectLst/>
-        </p:spPr>
-        <p:style>
-          <a:lnRef idx="1">
-            <a:schemeClr val="accent1"/>
-          </a:lnRef>
-          <a:fillRef idx="3">
-            <a:schemeClr val="accent1"/>
-          </a:fillRef>
-          <a:effectRef idx="2">
-            <a:schemeClr val="accent1"/>
-          </a:effectRef>
-          <a:fontRef idx="minor">
-            <a:schemeClr val="lt1"/>
-          </a:fontRef>
-        </p:style>
-        <p:txBody>
-          <a:bodyPr rtlCol="0" anchor="ctr" lIns="0" rIns="0"/>
-          <a:lstStyle/>
-          <a:p>
-            <a:pPr algn="ctr"/>
-          </a:p>
-        </p:txBody>
-      </p:sp>
-      <p:sp>
-        <p:nvSpPr>
           <p:cNvPr id="19" name="TextBox 18"/>
           <p:cNvSpPr txBox="1"/>
           <p:nvPr/>
@@ -10122,50 +9814,6 @@
       </p:sp>
       <p:sp>
         <p:nvSpPr>
-          <p:cNvPr id="21" name="Rectangle 20"/>
-          <p:cNvSpPr/>
-          <p:nvPr/>
-        </p:nvSpPr>
-        <p:spPr>
-          <a:xfrm>
-            <a:off x="877824" y="3666744"/>
-            <a:ext cx="54864" cy="420624"/>
-          </a:xfrm>
-          <a:prstGeom prst="rect">
-            <a:avLst/>
-          </a:prstGeom>
-          <a:solidFill>
-            <a:srgbClr val="EA493F"/>
-          </a:solidFill>
-          <a:ln>
-            <a:noFill/>
-          </a:ln>
-          <a:effectLst/>
-        </p:spPr>
-        <p:style>
-          <a:lnRef idx="1">
-            <a:schemeClr val="accent1"/>
-          </a:lnRef>
-          <a:fillRef idx="3">
-            <a:schemeClr val="accent1"/>
-          </a:fillRef>
-          <a:effectRef idx="2">
-            <a:schemeClr val="accent1"/>
-          </a:effectRef>
-          <a:fontRef idx="minor">
-            <a:schemeClr val="lt1"/>
-          </a:fontRef>
-        </p:style>
-        <p:txBody>
-          <a:bodyPr rtlCol="0" anchor="ctr" lIns="0" rIns="0"/>
-          <a:lstStyle/>
-          <a:p>
-            <a:pPr algn="ctr"/>
-          </a:p>
-        </p:txBody>
-      </p:sp>
-      <p:sp>
-        <p:nvSpPr>
           <p:cNvPr id="22" name="TextBox 21"/>
           <p:cNvSpPr txBox="1"/>
           <p:nvPr/>
@@ -10247,50 +9895,6 @@
       </p:sp>
       <p:sp>
         <p:nvSpPr>
-          <p:cNvPr id="24" name="Rectangle 23"/>
-          <p:cNvSpPr/>
-          <p:nvPr/>
-        </p:nvSpPr>
-        <p:spPr>
-          <a:xfrm>
-            <a:off x="3465576" y="3666744"/>
-            <a:ext cx="54864" cy="420624"/>
-          </a:xfrm>
-          <a:prstGeom prst="rect">
-            <a:avLst/>
-          </a:prstGeom>
-          <a:solidFill>
-            <a:srgbClr val="EA493F"/>
-          </a:solidFill>
-          <a:ln>
-            <a:noFill/>
-          </a:ln>
-          <a:effectLst/>
-        </p:spPr>
-        <p:style>
-          <a:lnRef idx="1">
-            <a:schemeClr val="accent1"/>
-          </a:lnRef>
-          <a:fillRef idx="3">
-            <a:schemeClr val="accent1"/>
-          </a:fillRef>
-          <a:effectRef idx="2">
-            <a:schemeClr val="accent1"/>
-          </a:effectRef>
-          <a:fontRef idx="minor">
-            <a:schemeClr val="lt1"/>
-          </a:fontRef>
-        </p:style>
-        <p:txBody>
-          <a:bodyPr rtlCol="0" anchor="ctr" lIns="0" rIns="0"/>
-          <a:lstStyle/>
-          <a:p>
-            <a:pPr algn="ctr"/>
-          </a:p>
-        </p:txBody>
-      </p:sp>
-      <p:sp>
-        <p:nvSpPr>
           <p:cNvPr id="25" name="TextBox 24"/>
           <p:cNvSpPr txBox="1"/>
           <p:nvPr/>
@@ -10372,50 +9976,6 @@
       </p:sp>
       <p:sp>
         <p:nvSpPr>
-          <p:cNvPr id="27" name="Rectangle 26"/>
-          <p:cNvSpPr/>
-          <p:nvPr/>
-        </p:nvSpPr>
-        <p:spPr>
-          <a:xfrm>
-            <a:off x="877824" y="4165091"/>
-            <a:ext cx="54864" cy="420624"/>
-          </a:xfrm>
-          <a:prstGeom prst="rect">
-            <a:avLst/>
-          </a:prstGeom>
-          <a:solidFill>
-            <a:srgbClr val="EA493F"/>
-          </a:solidFill>
-          <a:ln>
-            <a:noFill/>
-          </a:ln>
-          <a:effectLst/>
-        </p:spPr>
-        <p:style>
-          <a:lnRef idx="1">
-            <a:schemeClr val="accent1"/>
-          </a:lnRef>
-          <a:fillRef idx="3">
-            <a:schemeClr val="accent1"/>
-          </a:fillRef>
-          <a:effectRef idx="2">
-            <a:schemeClr val="accent1"/>
-          </a:effectRef>
-          <a:fontRef idx="minor">
-            <a:schemeClr val="lt1"/>
-          </a:fontRef>
-        </p:style>
-        <p:txBody>
-          <a:bodyPr rtlCol="0" anchor="ctr" lIns="0" rIns="0"/>
-          <a:lstStyle/>
-          <a:p>
-            <a:pPr algn="ctr"/>
-          </a:p>
-        </p:txBody>
-      </p:sp>
-      <p:sp>
-        <p:nvSpPr>
           <p:cNvPr id="28" name="TextBox 27"/>
           <p:cNvSpPr txBox="1"/>
           <p:nvPr/>
@@ -10497,50 +10057,6 @@
       </p:sp>
       <p:sp>
         <p:nvSpPr>
-          <p:cNvPr id="30" name="Rectangle 29"/>
-          <p:cNvSpPr/>
-          <p:nvPr/>
-        </p:nvSpPr>
-        <p:spPr>
-          <a:xfrm>
-            <a:off x="3465576" y="4165091"/>
-            <a:ext cx="54864" cy="420624"/>
-          </a:xfrm>
-          <a:prstGeom prst="rect">
-            <a:avLst/>
-          </a:prstGeom>
-          <a:solidFill>
-            <a:srgbClr val="EA493F"/>
-          </a:solidFill>
-          <a:ln>
-            <a:noFill/>
-          </a:ln>
-          <a:effectLst/>
-        </p:spPr>
-        <p:style>
-          <a:lnRef idx="1">
-            <a:schemeClr val="accent1"/>
-          </a:lnRef>
-          <a:fillRef idx="3">
-            <a:schemeClr val="accent1"/>
-          </a:fillRef>
-          <a:effectRef idx="2">
-            <a:schemeClr val="accent1"/>
-          </a:effectRef>
-          <a:fontRef idx="minor">
-            <a:schemeClr val="lt1"/>
-          </a:fontRef>
-        </p:style>
-        <p:txBody>
-          <a:bodyPr rtlCol="0" anchor="ctr" lIns="0" rIns="0"/>
-          <a:lstStyle/>
-          <a:p>
-            <a:pPr algn="ctr"/>
-          </a:p>
-        </p:txBody>
-      </p:sp>
-      <p:sp>
-        <p:nvSpPr>
           <p:cNvPr id="31" name="TextBox 30"/>
           <p:cNvSpPr txBox="1"/>
           <p:nvPr/>
@@ -10622,50 +10138,6 @@
       </p:sp>
       <p:sp>
         <p:nvSpPr>
-          <p:cNvPr id="33" name="Rectangle 32"/>
-          <p:cNvSpPr/>
-          <p:nvPr/>
-        </p:nvSpPr>
-        <p:spPr>
-          <a:xfrm>
-            <a:off x="877824" y="4663440"/>
-            <a:ext cx="54864" cy="420624"/>
-          </a:xfrm>
-          <a:prstGeom prst="rect">
-            <a:avLst/>
-          </a:prstGeom>
-          <a:solidFill>
-            <a:srgbClr val="EA493F"/>
-          </a:solidFill>
-          <a:ln>
-            <a:noFill/>
-          </a:ln>
-          <a:effectLst/>
-        </p:spPr>
-        <p:style>
-          <a:lnRef idx="1">
-            <a:schemeClr val="accent1"/>
-          </a:lnRef>
-          <a:fillRef idx="3">
-            <a:schemeClr val="accent1"/>
-          </a:fillRef>
-          <a:effectRef idx="2">
-            <a:schemeClr val="accent1"/>
-          </a:effectRef>
-          <a:fontRef idx="minor">
-            <a:schemeClr val="lt1"/>
-          </a:fontRef>
-        </p:style>
-        <p:txBody>
-          <a:bodyPr rtlCol="0" anchor="ctr" lIns="0" rIns="0"/>
-          <a:lstStyle/>
-          <a:p>
-            <a:pPr algn="ctr"/>
-          </a:p>
-        </p:txBody>
-      </p:sp>
-      <p:sp>
-        <p:nvSpPr>
           <p:cNvPr id="34" name="TextBox 33"/>
           <p:cNvSpPr txBox="1"/>
           <p:nvPr/>
@@ -10747,50 +10219,6 @@
       </p:sp>
       <p:sp>
         <p:nvSpPr>
-          <p:cNvPr id="36" name="Rectangle 35"/>
-          <p:cNvSpPr/>
-          <p:nvPr/>
-        </p:nvSpPr>
-        <p:spPr>
-          <a:xfrm>
-            <a:off x="3465576" y="4663440"/>
-            <a:ext cx="54864" cy="420624"/>
-          </a:xfrm>
-          <a:prstGeom prst="rect">
-            <a:avLst/>
-          </a:prstGeom>
-          <a:solidFill>
-            <a:srgbClr val="EA493F"/>
-          </a:solidFill>
-          <a:ln>
-            <a:noFill/>
-          </a:ln>
-          <a:effectLst/>
-        </p:spPr>
-        <p:style>
-          <a:lnRef idx="1">
-            <a:schemeClr val="accent1"/>
-          </a:lnRef>
-          <a:fillRef idx="3">
-            <a:schemeClr val="accent1"/>
-          </a:fillRef>
-          <a:effectRef idx="2">
-            <a:schemeClr val="accent1"/>
-          </a:effectRef>
-          <a:fontRef idx="minor">
-            <a:schemeClr val="lt1"/>
-          </a:fontRef>
-        </p:style>
-        <p:txBody>
-          <a:bodyPr rtlCol="0" anchor="ctr" lIns="0" rIns="0"/>
-          <a:lstStyle/>
-          <a:p>
-            <a:pPr algn="ctr"/>
-          </a:p>
-        </p:txBody>
-      </p:sp>
-      <p:sp>
-        <p:nvSpPr>
           <p:cNvPr id="37" name="TextBox 36"/>
           <p:cNvSpPr txBox="1"/>
           <p:nvPr/>
@@ -10872,50 +10300,6 @@
       </p:sp>
       <p:sp>
         <p:nvSpPr>
-          <p:cNvPr id="39" name="Rectangle 38"/>
-          <p:cNvSpPr/>
-          <p:nvPr/>
-        </p:nvSpPr>
-        <p:spPr>
-          <a:xfrm>
-            <a:off x="877824" y="5161788"/>
-            <a:ext cx="54864" cy="420624"/>
-          </a:xfrm>
-          <a:prstGeom prst="rect">
-            <a:avLst/>
-          </a:prstGeom>
-          <a:solidFill>
-            <a:srgbClr val="EA493F"/>
-          </a:solidFill>
-          <a:ln>
-            <a:noFill/>
-          </a:ln>
-          <a:effectLst/>
-        </p:spPr>
-        <p:style>
-          <a:lnRef idx="1">
-            <a:schemeClr val="accent1"/>
-          </a:lnRef>
-          <a:fillRef idx="3">
-            <a:schemeClr val="accent1"/>
-          </a:fillRef>
-          <a:effectRef idx="2">
-            <a:schemeClr val="accent1"/>
-          </a:effectRef>
-          <a:fontRef idx="minor">
-            <a:schemeClr val="lt1"/>
-          </a:fontRef>
-        </p:style>
-        <p:txBody>
-          <a:bodyPr rtlCol="0" anchor="ctr" lIns="0" rIns="0"/>
-          <a:lstStyle/>
-          <a:p>
-            <a:pPr algn="ctr"/>
-          </a:p>
-        </p:txBody>
-      </p:sp>
-      <p:sp>
-        <p:nvSpPr>
           <p:cNvPr id="40" name="TextBox 39"/>
           <p:cNvSpPr txBox="1"/>
           <p:nvPr/>
@@ -10997,50 +10381,6 @@
       </p:sp>
       <p:sp>
         <p:nvSpPr>
-          <p:cNvPr id="42" name="Rectangle 41"/>
-          <p:cNvSpPr/>
-          <p:nvPr/>
-        </p:nvSpPr>
-        <p:spPr>
-          <a:xfrm>
-            <a:off x="3465576" y="5161788"/>
-            <a:ext cx="54864" cy="420624"/>
-          </a:xfrm>
-          <a:prstGeom prst="rect">
-            <a:avLst/>
-          </a:prstGeom>
-          <a:solidFill>
-            <a:srgbClr val="EA493F"/>
-          </a:solidFill>
-          <a:ln>
-            <a:noFill/>
-          </a:ln>
-          <a:effectLst/>
-        </p:spPr>
-        <p:style>
-          <a:lnRef idx="1">
-            <a:schemeClr val="accent1"/>
-          </a:lnRef>
-          <a:fillRef idx="3">
-            <a:schemeClr val="accent1"/>
-          </a:fillRef>
-          <a:effectRef idx="2">
-            <a:schemeClr val="accent1"/>
-          </a:effectRef>
-          <a:fontRef idx="minor">
-            <a:schemeClr val="lt1"/>
-          </a:fontRef>
-        </p:style>
-        <p:txBody>
-          <a:bodyPr rtlCol="0" anchor="ctr" lIns="0" rIns="0"/>
-          <a:lstStyle/>
-          <a:p>
-            <a:pPr algn="ctr"/>
-          </a:p>
-        </p:txBody>
-      </p:sp>
-      <p:sp>
-        <p:nvSpPr>
           <p:cNvPr id="43" name="TextBox 42"/>
           <p:cNvSpPr txBox="1"/>
           <p:nvPr/>
@@ -11201,50 +10541,6 @@
       </p:sp>
       <p:sp>
         <p:nvSpPr>
-          <p:cNvPr id="47" name="Rectangle 46"/>
-          <p:cNvSpPr/>
-          <p:nvPr/>
-        </p:nvSpPr>
-        <p:spPr>
-          <a:xfrm>
-            <a:off x="6291072" y="2670048"/>
-            <a:ext cx="54864" cy="420624"/>
-          </a:xfrm>
-          <a:prstGeom prst="rect">
-            <a:avLst/>
-          </a:prstGeom>
-          <a:solidFill>
-            <a:srgbClr val="EA493F"/>
-          </a:solidFill>
-          <a:ln>
-            <a:noFill/>
-          </a:ln>
-          <a:effectLst/>
-        </p:spPr>
-        <p:style>
-          <a:lnRef idx="1">
-            <a:schemeClr val="accent1"/>
-          </a:lnRef>
-          <a:fillRef idx="3">
-            <a:schemeClr val="accent1"/>
-          </a:fillRef>
-          <a:effectRef idx="2">
-            <a:schemeClr val="accent1"/>
-          </a:effectRef>
-          <a:fontRef idx="minor">
-            <a:schemeClr val="lt1"/>
-          </a:fontRef>
-        </p:style>
-        <p:txBody>
-          <a:bodyPr rtlCol="0" anchor="ctr" lIns="0" rIns="0"/>
-          <a:lstStyle/>
-          <a:p>
-            <a:pPr algn="ctr"/>
-          </a:p>
-        </p:txBody>
-      </p:sp>
-      <p:sp>
-        <p:nvSpPr>
           <p:cNvPr id="48" name="TextBox 47"/>
           <p:cNvSpPr txBox="1"/>
           <p:nvPr/>
@@ -11326,50 +10622,6 @@
       </p:sp>
       <p:sp>
         <p:nvSpPr>
-          <p:cNvPr id="50" name="Rectangle 49"/>
-          <p:cNvSpPr/>
-          <p:nvPr/>
-        </p:nvSpPr>
-        <p:spPr>
-          <a:xfrm>
-            <a:off x="8878824" y="2670048"/>
-            <a:ext cx="54864" cy="420624"/>
-          </a:xfrm>
-          <a:prstGeom prst="rect">
-            <a:avLst/>
-          </a:prstGeom>
-          <a:solidFill>
-            <a:srgbClr val="EA493F"/>
-          </a:solidFill>
-          <a:ln>
-            <a:noFill/>
-          </a:ln>
-          <a:effectLst/>
-        </p:spPr>
-        <p:style>
-          <a:lnRef idx="1">
-            <a:schemeClr val="accent1"/>
-          </a:lnRef>
-          <a:fillRef idx="3">
-            <a:schemeClr val="accent1"/>
-          </a:fillRef>
-          <a:effectRef idx="2">
-            <a:schemeClr val="accent1"/>
-          </a:effectRef>
-          <a:fontRef idx="minor">
-            <a:schemeClr val="lt1"/>
-          </a:fontRef>
-        </p:style>
-        <p:txBody>
-          <a:bodyPr rtlCol="0" anchor="ctr" lIns="0" rIns="0"/>
-          <a:lstStyle/>
-          <a:p>
-            <a:pPr algn="ctr"/>
-          </a:p>
-        </p:txBody>
-      </p:sp>
-      <p:sp>
-        <p:nvSpPr>
           <p:cNvPr id="51" name="TextBox 50"/>
           <p:cNvSpPr txBox="1"/>
           <p:nvPr/>
@@ -11451,50 +10703,6 @@
       </p:sp>
       <p:sp>
         <p:nvSpPr>
-          <p:cNvPr id="53" name="Rectangle 52"/>
-          <p:cNvSpPr/>
-          <p:nvPr/>
-        </p:nvSpPr>
-        <p:spPr>
-          <a:xfrm>
-            <a:off x="6291072" y="3168396"/>
-            <a:ext cx="54864" cy="420624"/>
-          </a:xfrm>
-          <a:prstGeom prst="rect">
-            <a:avLst/>
-          </a:prstGeom>
-          <a:solidFill>
-            <a:srgbClr val="EA493F"/>
-          </a:solidFill>
-          <a:ln>
-            <a:noFill/>
-          </a:ln>
-          <a:effectLst/>
-        </p:spPr>
-        <p:style>
-          <a:lnRef idx="1">
-            <a:schemeClr val="accent1"/>
-          </a:lnRef>
-          <a:fillRef idx="3">
-            <a:schemeClr val="accent1"/>
-          </a:fillRef>
-          <a:effectRef idx="2">
-            <a:schemeClr val="accent1"/>
-          </a:effectRef>
-          <a:fontRef idx="minor">
-            <a:schemeClr val="lt1"/>
-          </a:fontRef>
-        </p:style>
-        <p:txBody>
-          <a:bodyPr rtlCol="0" anchor="ctr" lIns="0" rIns="0"/>
-          <a:lstStyle/>
-          <a:p>
-            <a:pPr algn="ctr"/>
-          </a:p>
-        </p:txBody>
-      </p:sp>
-      <p:sp>
-        <p:nvSpPr>
           <p:cNvPr id="54" name="TextBox 53"/>
           <p:cNvSpPr txBox="1"/>
           <p:nvPr/>
@@ -11576,50 +10784,6 @@
       </p:sp>
       <p:sp>
         <p:nvSpPr>
-          <p:cNvPr id="56" name="Rectangle 55"/>
-          <p:cNvSpPr/>
-          <p:nvPr/>
-        </p:nvSpPr>
-        <p:spPr>
-          <a:xfrm>
-            <a:off x="8878824" y="3168396"/>
-            <a:ext cx="54864" cy="420624"/>
-          </a:xfrm>
-          <a:prstGeom prst="rect">
-            <a:avLst/>
-          </a:prstGeom>
-          <a:solidFill>
-            <a:srgbClr val="EA493F"/>
-          </a:solidFill>
-          <a:ln>
-            <a:noFill/>
-          </a:ln>
-          <a:effectLst/>
-        </p:spPr>
-        <p:style>
-          <a:lnRef idx="1">
-            <a:schemeClr val="accent1"/>
-          </a:lnRef>
-          <a:fillRef idx="3">
-            <a:schemeClr val="accent1"/>
-          </a:fillRef>
-          <a:effectRef idx="2">
-            <a:schemeClr val="accent1"/>
-          </a:effectRef>
-          <a:fontRef idx="minor">
-            <a:schemeClr val="lt1"/>
-          </a:fontRef>
-        </p:style>
-        <p:txBody>
-          <a:bodyPr rtlCol="0" anchor="ctr" lIns="0" rIns="0"/>
-          <a:lstStyle/>
-          <a:p>
-            <a:pPr algn="ctr"/>
-          </a:p>
-        </p:txBody>
-      </p:sp>
-      <p:sp>
-        <p:nvSpPr>
           <p:cNvPr id="57" name="TextBox 56"/>
           <p:cNvSpPr txBox="1"/>
           <p:nvPr/>
@@ -11701,50 +10865,6 @@
       </p:sp>
       <p:sp>
         <p:nvSpPr>
-          <p:cNvPr id="59" name="Rectangle 58"/>
-          <p:cNvSpPr/>
-          <p:nvPr/>
-        </p:nvSpPr>
-        <p:spPr>
-          <a:xfrm>
-            <a:off x="6291072" y="3666744"/>
-            <a:ext cx="54864" cy="420624"/>
-          </a:xfrm>
-          <a:prstGeom prst="rect">
-            <a:avLst/>
-          </a:prstGeom>
-          <a:solidFill>
-            <a:srgbClr val="EA493F"/>
-          </a:solidFill>
-          <a:ln>
-            <a:noFill/>
-          </a:ln>
-          <a:effectLst/>
-        </p:spPr>
-        <p:style>
-          <a:lnRef idx="1">
-            <a:schemeClr val="accent1"/>
-          </a:lnRef>
-          <a:fillRef idx="3">
-            <a:schemeClr val="accent1"/>
-          </a:fillRef>
-          <a:effectRef idx="2">
-            <a:schemeClr val="accent1"/>
-          </a:effectRef>
-          <a:fontRef idx="minor">
-            <a:schemeClr val="lt1"/>
-          </a:fontRef>
-        </p:style>
-        <p:txBody>
-          <a:bodyPr rtlCol="0" anchor="ctr" lIns="0" rIns="0"/>
-          <a:lstStyle/>
-          <a:p>
-            <a:pPr algn="ctr"/>
-          </a:p>
-        </p:txBody>
-      </p:sp>
-      <p:sp>
-        <p:nvSpPr>
           <p:cNvPr id="60" name="TextBox 59"/>
           <p:cNvSpPr txBox="1"/>
           <p:nvPr/>
@@ -11826,50 +10946,6 @@
       </p:sp>
       <p:sp>
         <p:nvSpPr>
-          <p:cNvPr id="62" name="Rectangle 61"/>
-          <p:cNvSpPr/>
-          <p:nvPr/>
-        </p:nvSpPr>
-        <p:spPr>
-          <a:xfrm>
-            <a:off x="8878824" y="3666744"/>
-            <a:ext cx="54864" cy="420624"/>
-          </a:xfrm>
-          <a:prstGeom prst="rect">
-            <a:avLst/>
-          </a:prstGeom>
-          <a:solidFill>
-            <a:srgbClr val="EA493F"/>
-          </a:solidFill>
-          <a:ln>
-            <a:noFill/>
-          </a:ln>
-          <a:effectLst/>
-        </p:spPr>
-        <p:style>
-          <a:lnRef idx="1">
-            <a:schemeClr val="accent1"/>
-          </a:lnRef>
-          <a:fillRef idx="3">
-            <a:schemeClr val="accent1"/>
-          </a:fillRef>
-          <a:effectRef idx="2">
-            <a:schemeClr val="accent1"/>
-          </a:effectRef>
-          <a:fontRef idx="minor">
-            <a:schemeClr val="lt1"/>
-          </a:fontRef>
-        </p:style>
-        <p:txBody>
-          <a:bodyPr rtlCol="0" anchor="ctr" lIns="0" rIns="0"/>
-          <a:lstStyle/>
-          <a:p>
-            <a:pPr algn="ctr"/>
-          </a:p>
-        </p:txBody>
-      </p:sp>
-      <p:sp>
-        <p:nvSpPr>
           <p:cNvPr id="63" name="TextBox 62"/>
           <p:cNvSpPr txBox="1"/>
           <p:nvPr/>
@@ -11951,50 +11027,6 @@
       </p:sp>
       <p:sp>
         <p:nvSpPr>
-          <p:cNvPr id="65" name="Rectangle 64"/>
-          <p:cNvSpPr/>
-          <p:nvPr/>
-        </p:nvSpPr>
-        <p:spPr>
-          <a:xfrm>
-            <a:off x="6291072" y="4165091"/>
-            <a:ext cx="54864" cy="420624"/>
-          </a:xfrm>
-          <a:prstGeom prst="rect">
-            <a:avLst/>
-          </a:prstGeom>
-          <a:solidFill>
-            <a:srgbClr val="EA493F"/>
-          </a:solidFill>
-          <a:ln>
-            <a:noFill/>
-          </a:ln>
-          <a:effectLst/>
-        </p:spPr>
-        <p:style>
-          <a:lnRef idx="1">
-            <a:schemeClr val="accent1"/>
-          </a:lnRef>
-          <a:fillRef idx="3">
-            <a:schemeClr val="accent1"/>
-          </a:fillRef>
-          <a:effectRef idx="2">
-            <a:schemeClr val="accent1"/>
-          </a:effectRef>
-          <a:fontRef idx="minor">
-            <a:schemeClr val="lt1"/>
-          </a:fontRef>
-        </p:style>
-        <p:txBody>
-          <a:bodyPr rtlCol="0" anchor="ctr" lIns="0" rIns="0"/>
-          <a:lstStyle/>
-          <a:p>
-            <a:pPr algn="ctr"/>
-          </a:p>
-        </p:txBody>
-      </p:sp>
-      <p:sp>
-        <p:nvSpPr>
           <p:cNvPr id="66" name="TextBox 65"/>
           <p:cNvSpPr txBox="1"/>
           <p:nvPr/>
@@ -12076,50 +11108,6 @@
       </p:sp>
       <p:sp>
         <p:nvSpPr>
-          <p:cNvPr id="68" name="Rectangle 67"/>
-          <p:cNvSpPr/>
-          <p:nvPr/>
-        </p:nvSpPr>
-        <p:spPr>
-          <a:xfrm>
-            <a:off x="8878824" y="4165091"/>
-            <a:ext cx="54864" cy="420624"/>
-          </a:xfrm>
-          <a:prstGeom prst="rect">
-            <a:avLst/>
-          </a:prstGeom>
-          <a:solidFill>
-            <a:srgbClr val="EA493F"/>
-          </a:solidFill>
-          <a:ln>
-            <a:noFill/>
-          </a:ln>
-          <a:effectLst/>
-        </p:spPr>
-        <p:style>
-          <a:lnRef idx="1">
-            <a:schemeClr val="accent1"/>
-          </a:lnRef>
-          <a:fillRef idx="3">
-            <a:schemeClr val="accent1"/>
-          </a:fillRef>
-          <a:effectRef idx="2">
-            <a:schemeClr val="accent1"/>
-          </a:effectRef>
-          <a:fontRef idx="minor">
-            <a:schemeClr val="lt1"/>
-          </a:fontRef>
-        </p:style>
-        <p:txBody>
-          <a:bodyPr rtlCol="0" anchor="ctr" lIns="0" rIns="0"/>
-          <a:lstStyle/>
-          <a:p>
-            <a:pPr algn="ctr"/>
-          </a:p>
-        </p:txBody>
-      </p:sp>
-      <p:sp>
-        <p:nvSpPr>
           <p:cNvPr id="69" name="TextBox 68"/>
           <p:cNvSpPr txBox="1"/>
           <p:nvPr/>
@@ -12201,50 +11189,6 @@
       </p:sp>
       <p:sp>
         <p:nvSpPr>
-          <p:cNvPr id="71" name="Rectangle 70"/>
-          <p:cNvSpPr/>
-          <p:nvPr/>
-        </p:nvSpPr>
-        <p:spPr>
-          <a:xfrm>
-            <a:off x="6291072" y="4663440"/>
-            <a:ext cx="54864" cy="420624"/>
-          </a:xfrm>
-          <a:prstGeom prst="rect">
-            <a:avLst/>
-          </a:prstGeom>
-          <a:solidFill>
-            <a:srgbClr val="EA493F"/>
-          </a:solidFill>
-          <a:ln>
-            <a:noFill/>
-          </a:ln>
-          <a:effectLst/>
-        </p:spPr>
-        <p:style>
-          <a:lnRef idx="1">
-            <a:schemeClr val="accent1"/>
-          </a:lnRef>
-          <a:fillRef idx="3">
-            <a:schemeClr val="accent1"/>
-          </a:fillRef>
-          <a:effectRef idx="2">
-            <a:schemeClr val="accent1"/>
-          </a:effectRef>
-          <a:fontRef idx="minor">
-            <a:schemeClr val="lt1"/>
-          </a:fontRef>
-        </p:style>
-        <p:txBody>
-          <a:bodyPr rtlCol="0" anchor="ctr" lIns="0" rIns="0"/>
-          <a:lstStyle/>
-          <a:p>
-            <a:pPr algn="ctr"/>
-          </a:p>
-        </p:txBody>
-      </p:sp>
-      <p:sp>
-        <p:nvSpPr>
           <p:cNvPr id="72" name="TextBox 71"/>
           <p:cNvSpPr txBox="1"/>
           <p:nvPr/>
@@ -12326,50 +11270,6 @@
       </p:sp>
       <p:sp>
         <p:nvSpPr>
-          <p:cNvPr id="74" name="Rectangle 73"/>
-          <p:cNvSpPr/>
-          <p:nvPr/>
-        </p:nvSpPr>
-        <p:spPr>
-          <a:xfrm>
-            <a:off x="8878824" y="4663440"/>
-            <a:ext cx="54864" cy="420624"/>
-          </a:xfrm>
-          <a:prstGeom prst="rect">
-            <a:avLst/>
-          </a:prstGeom>
-          <a:solidFill>
-            <a:srgbClr val="EA493F"/>
-          </a:solidFill>
-          <a:ln>
-            <a:noFill/>
-          </a:ln>
-          <a:effectLst/>
-        </p:spPr>
-        <p:style>
-          <a:lnRef idx="1">
-            <a:schemeClr val="accent1"/>
-          </a:lnRef>
-          <a:fillRef idx="3">
-            <a:schemeClr val="accent1"/>
-          </a:fillRef>
-          <a:effectRef idx="2">
-            <a:schemeClr val="accent1"/>
-          </a:effectRef>
-          <a:fontRef idx="minor">
-            <a:schemeClr val="lt1"/>
-          </a:fontRef>
-        </p:style>
-        <p:txBody>
-          <a:bodyPr rtlCol="0" anchor="ctr" lIns="0" rIns="0"/>
-          <a:lstStyle/>
-          <a:p>
-            <a:pPr algn="ctr"/>
-          </a:p>
-        </p:txBody>
-      </p:sp>
-      <p:sp>
-        <p:nvSpPr>
           <p:cNvPr id="75" name="TextBox 74"/>
           <p:cNvSpPr txBox="1"/>
           <p:nvPr/>
@@ -12451,50 +11351,6 @@
       </p:sp>
       <p:sp>
         <p:nvSpPr>
-          <p:cNvPr id="77" name="Rectangle 76"/>
-          <p:cNvSpPr/>
-          <p:nvPr/>
-        </p:nvSpPr>
-        <p:spPr>
-          <a:xfrm>
-            <a:off x="6291072" y="5161788"/>
-            <a:ext cx="54864" cy="420624"/>
-          </a:xfrm>
-          <a:prstGeom prst="rect">
-            <a:avLst/>
-          </a:prstGeom>
-          <a:solidFill>
-            <a:srgbClr val="EA493F"/>
-          </a:solidFill>
-          <a:ln>
-            <a:noFill/>
-          </a:ln>
-          <a:effectLst/>
-        </p:spPr>
-        <p:style>
-          <a:lnRef idx="1">
-            <a:schemeClr val="accent1"/>
-          </a:lnRef>
-          <a:fillRef idx="3">
-            <a:schemeClr val="accent1"/>
-          </a:fillRef>
-          <a:effectRef idx="2">
-            <a:schemeClr val="accent1"/>
-          </a:effectRef>
-          <a:fontRef idx="minor">
-            <a:schemeClr val="lt1"/>
-          </a:fontRef>
-        </p:style>
-        <p:txBody>
-          <a:bodyPr rtlCol="0" anchor="ctr" lIns="0" rIns="0"/>
-          <a:lstStyle/>
-          <a:p>
-            <a:pPr algn="ctr"/>
-          </a:p>
-        </p:txBody>
-      </p:sp>
-      <p:sp>
-        <p:nvSpPr>
           <p:cNvPr id="78" name="TextBox 77"/>
           <p:cNvSpPr txBox="1"/>
           <p:nvPr/>
@@ -12549,50 +11405,6 @@
             <a:solidFill>
               <a:srgbClr val="E4E4E0"/>
             </a:solidFill>
-          </a:ln>
-          <a:effectLst/>
-        </p:spPr>
-        <p:style>
-          <a:lnRef idx="1">
-            <a:schemeClr val="accent1"/>
-          </a:lnRef>
-          <a:fillRef idx="3">
-            <a:schemeClr val="accent1"/>
-          </a:fillRef>
-          <a:effectRef idx="2">
-            <a:schemeClr val="accent1"/>
-          </a:effectRef>
-          <a:fontRef idx="minor">
-            <a:schemeClr val="lt1"/>
-          </a:fontRef>
-        </p:style>
-        <p:txBody>
-          <a:bodyPr rtlCol="0" anchor="ctr" lIns="0" rIns="0"/>
-          <a:lstStyle/>
-          <a:p>
-            <a:pPr algn="ctr"/>
-          </a:p>
-        </p:txBody>
-      </p:sp>
-      <p:sp>
-        <p:nvSpPr>
-          <p:cNvPr id="80" name="Rectangle 79"/>
-          <p:cNvSpPr/>
-          <p:nvPr/>
-        </p:nvSpPr>
-        <p:spPr>
-          <a:xfrm>
-            <a:off x="8878824" y="5161788"/>
-            <a:ext cx="54864" cy="420624"/>
-          </a:xfrm>
-          <a:prstGeom prst="rect">
-            <a:avLst/>
-          </a:prstGeom>
-          <a:solidFill>
-            <a:srgbClr val="EA493F"/>
-          </a:solidFill>
-          <a:ln>
-            <a:noFill/>
           </a:ln>
           <a:effectLst/>
         </p:spPr>
@@ -15991,50 +14803,6 @@
       </p:sp>
       <p:sp>
         <p:nvSpPr>
-          <p:cNvPr id="14" name="Rectangle 13"/>
-          <p:cNvSpPr/>
-          <p:nvPr/>
-        </p:nvSpPr>
-        <p:spPr>
-          <a:xfrm>
-            <a:off x="877824" y="3429000"/>
-            <a:ext cx="91440" cy="1417320"/>
-          </a:xfrm>
-          <a:prstGeom prst="rect">
-            <a:avLst/>
-          </a:prstGeom>
-          <a:solidFill>
-            <a:srgbClr val="EA493F"/>
-          </a:solidFill>
-          <a:ln>
-            <a:noFill/>
-          </a:ln>
-          <a:effectLst/>
-        </p:spPr>
-        <p:style>
-          <a:lnRef idx="1">
-            <a:schemeClr val="accent1"/>
-          </a:lnRef>
-          <a:fillRef idx="3">
-            <a:schemeClr val="accent1"/>
-          </a:fillRef>
-          <a:effectRef idx="2">
-            <a:schemeClr val="accent1"/>
-          </a:effectRef>
-          <a:fontRef idx="minor">
-            <a:schemeClr val="lt1"/>
-          </a:fontRef>
-        </p:style>
-        <p:txBody>
-          <a:bodyPr rtlCol="0" anchor="ctr" lIns="0" rIns="0"/>
-          <a:lstStyle/>
-          <a:p>
-            <a:pPr algn="ctr"/>
-          </a:p>
-        </p:txBody>
-      </p:sp>
-      <p:sp>
-        <p:nvSpPr>
           <p:cNvPr id="15" name="TextBox 14"/>
           <p:cNvSpPr txBox="1"/>
           <p:nvPr/>
@@ -16163,50 +14931,6 @@
             <a:solidFill>
               <a:srgbClr val="E4E4E0"/>
             </a:solidFill>
-          </a:ln>
-          <a:effectLst/>
-        </p:spPr>
-        <p:style>
-          <a:lnRef idx="1">
-            <a:schemeClr val="accent1"/>
-          </a:lnRef>
-          <a:fillRef idx="3">
-            <a:schemeClr val="accent1"/>
-          </a:fillRef>
-          <a:effectRef idx="2">
-            <a:schemeClr val="accent1"/>
-          </a:effectRef>
-          <a:fontRef idx="minor">
-            <a:schemeClr val="lt1"/>
-          </a:fontRef>
-        </p:style>
-        <p:txBody>
-          <a:bodyPr rtlCol="0" anchor="ctr" lIns="0" rIns="0"/>
-          <a:lstStyle/>
-          <a:p>
-            <a:pPr algn="ctr"/>
-          </a:p>
-        </p:txBody>
-      </p:sp>
-      <p:sp>
-        <p:nvSpPr>
-          <p:cNvPr id="19" name="Rectangle 18"/>
-          <p:cNvSpPr/>
-          <p:nvPr/>
-        </p:nvSpPr>
-        <p:spPr>
-          <a:xfrm>
-            <a:off x="6291072" y="3429000"/>
-            <a:ext cx="91440" cy="1417320"/>
-          </a:xfrm>
-          <a:prstGeom prst="rect">
-            <a:avLst/>
-          </a:prstGeom>
-          <a:solidFill>
-            <a:srgbClr val="111111"/>
-          </a:solidFill>
-          <a:ln>
-            <a:noFill/>
           </a:ln>
           <a:effectLst/>
         </p:spPr>
@@ -22189,50 +20913,6 @@
       </p:sp>
       <p:sp>
         <p:nvSpPr>
-          <p:cNvPr id="7" name="Rectangle 6"/>
-          <p:cNvSpPr/>
-          <p:nvPr/>
-        </p:nvSpPr>
-        <p:spPr>
-          <a:xfrm>
-            <a:off x="877824" y="2194560"/>
-            <a:ext cx="91440" cy="1234440"/>
-          </a:xfrm>
-          <a:prstGeom prst="rect">
-            <a:avLst/>
-          </a:prstGeom>
-          <a:solidFill>
-            <a:srgbClr val="EA493F"/>
-          </a:solidFill>
-          <a:ln>
-            <a:noFill/>
-          </a:ln>
-          <a:effectLst/>
-        </p:spPr>
-        <p:style>
-          <a:lnRef idx="1">
-            <a:schemeClr val="accent1"/>
-          </a:lnRef>
-          <a:fillRef idx="3">
-            <a:schemeClr val="accent1"/>
-          </a:fillRef>
-          <a:effectRef idx="2">
-            <a:schemeClr val="accent1"/>
-          </a:effectRef>
-          <a:fontRef idx="minor">
-            <a:schemeClr val="lt1"/>
-          </a:fontRef>
-        </p:style>
-        <p:txBody>
-          <a:bodyPr rtlCol="0" anchor="ctr" lIns="0" rIns="0"/>
-          <a:lstStyle/>
-          <a:p>
-            <a:pPr algn="ctr"/>
-          </a:p>
-        </p:txBody>
-      </p:sp>
-      <p:sp>
-        <p:nvSpPr>
           <p:cNvPr id="8" name="TextBox 7"/>
           <p:cNvSpPr txBox="1"/>
           <p:nvPr/>
@@ -22384,50 +21064,6 @@
       </p:sp>
       <p:sp>
         <p:nvSpPr>
-          <p:cNvPr id="12" name="Rectangle 11"/>
-          <p:cNvSpPr/>
-          <p:nvPr/>
-        </p:nvSpPr>
-        <p:spPr>
-          <a:xfrm>
-            <a:off x="4480559" y="2194560"/>
-            <a:ext cx="91440" cy="1234440"/>
-          </a:xfrm>
-          <a:prstGeom prst="rect">
-            <a:avLst/>
-          </a:prstGeom>
-          <a:solidFill>
-            <a:srgbClr val="EA493F"/>
-          </a:solidFill>
-          <a:ln>
-            <a:noFill/>
-          </a:ln>
-          <a:effectLst/>
-        </p:spPr>
-        <p:style>
-          <a:lnRef idx="1">
-            <a:schemeClr val="accent1"/>
-          </a:lnRef>
-          <a:fillRef idx="3">
-            <a:schemeClr val="accent1"/>
-          </a:fillRef>
-          <a:effectRef idx="2">
-            <a:schemeClr val="accent1"/>
-          </a:effectRef>
-          <a:fontRef idx="minor">
-            <a:schemeClr val="lt1"/>
-          </a:fontRef>
-        </p:style>
-        <p:txBody>
-          <a:bodyPr rtlCol="0" anchor="ctr" lIns="0" rIns="0"/>
-          <a:lstStyle/>
-          <a:p>
-            <a:pPr algn="ctr"/>
-          </a:p>
-        </p:txBody>
-      </p:sp>
-      <p:sp>
-        <p:nvSpPr>
           <p:cNvPr id="13" name="TextBox 12"/>
           <p:cNvSpPr txBox="1"/>
           <p:nvPr/>
@@ -22552,50 +21188,6 @@
             <a:solidFill>
               <a:srgbClr val="E4E4E0"/>
             </a:solidFill>
-          </a:ln>
-          <a:effectLst/>
-        </p:spPr>
-        <p:style>
-          <a:lnRef idx="1">
-            <a:schemeClr val="accent1"/>
-          </a:lnRef>
-          <a:fillRef idx="3">
-            <a:schemeClr val="accent1"/>
-          </a:fillRef>
-          <a:effectRef idx="2">
-            <a:schemeClr val="accent1"/>
-          </a:effectRef>
-          <a:fontRef idx="minor">
-            <a:schemeClr val="lt1"/>
-          </a:fontRef>
-        </p:style>
-        <p:txBody>
-          <a:bodyPr rtlCol="0" anchor="ctr" lIns="0" rIns="0"/>
-          <a:lstStyle/>
-          <a:p>
-            <a:pPr algn="ctr"/>
-          </a:p>
-        </p:txBody>
-      </p:sp>
-      <p:sp>
-        <p:nvSpPr>
-          <p:cNvPr id="17" name="Rectangle 16"/>
-          <p:cNvSpPr/>
-          <p:nvPr/>
-        </p:nvSpPr>
-        <p:spPr>
-          <a:xfrm>
-            <a:off x="8083296" y="2194560"/>
-            <a:ext cx="91440" cy="1234440"/>
-          </a:xfrm>
-          <a:prstGeom prst="rect">
-            <a:avLst/>
-          </a:prstGeom>
-          <a:solidFill>
-            <a:srgbClr val="EA493F"/>
-          </a:solidFill>
-          <a:ln>
-            <a:noFill/>
           </a:ln>
           <a:effectLst/>
         </p:spPr>
@@ -23152,50 +21744,6 @@
       </p:sp>
       <p:sp>
         <p:nvSpPr>
-          <p:cNvPr id="7" name="Rectangle 6"/>
-          <p:cNvSpPr/>
-          <p:nvPr/>
-        </p:nvSpPr>
-        <p:spPr>
-          <a:xfrm>
-            <a:off x="877824" y="2157984"/>
-            <a:ext cx="91440" cy="1024128"/>
-          </a:xfrm>
-          <a:prstGeom prst="rect">
-            <a:avLst/>
-          </a:prstGeom>
-          <a:solidFill>
-            <a:srgbClr val="EA493F"/>
-          </a:solidFill>
-          <a:ln>
-            <a:noFill/>
-          </a:ln>
-          <a:effectLst/>
-        </p:spPr>
-        <p:style>
-          <a:lnRef idx="1">
-            <a:schemeClr val="accent1"/>
-          </a:lnRef>
-          <a:fillRef idx="3">
-            <a:schemeClr val="accent1"/>
-          </a:fillRef>
-          <a:effectRef idx="2">
-            <a:schemeClr val="accent1"/>
-          </a:effectRef>
-          <a:fontRef idx="minor">
-            <a:schemeClr val="lt1"/>
-          </a:fontRef>
-        </p:style>
-        <p:txBody>
-          <a:bodyPr rtlCol="0" anchor="ctr" lIns="0" rIns="0"/>
-          <a:lstStyle/>
-          <a:p>
-            <a:pPr algn="ctr"/>
-          </a:p>
-        </p:txBody>
-      </p:sp>
-      <p:sp>
-        <p:nvSpPr>
           <p:cNvPr id="8" name="TextBox 7"/>
           <p:cNvSpPr txBox="1"/>
           <p:nvPr/>
@@ -23347,50 +21895,6 @@
       </p:sp>
       <p:sp>
         <p:nvSpPr>
-          <p:cNvPr id="12" name="Rectangle 11"/>
-          <p:cNvSpPr/>
-          <p:nvPr/>
-        </p:nvSpPr>
-        <p:spPr>
-          <a:xfrm>
-            <a:off x="4480559" y="2157984"/>
-            <a:ext cx="91440" cy="1024128"/>
-          </a:xfrm>
-          <a:prstGeom prst="rect">
-            <a:avLst/>
-          </a:prstGeom>
-          <a:solidFill>
-            <a:srgbClr val="EA493F"/>
-          </a:solidFill>
-          <a:ln>
-            <a:noFill/>
-          </a:ln>
-          <a:effectLst/>
-        </p:spPr>
-        <p:style>
-          <a:lnRef idx="1">
-            <a:schemeClr val="accent1"/>
-          </a:lnRef>
-          <a:fillRef idx="3">
-            <a:schemeClr val="accent1"/>
-          </a:fillRef>
-          <a:effectRef idx="2">
-            <a:schemeClr val="accent1"/>
-          </a:effectRef>
-          <a:fontRef idx="minor">
-            <a:schemeClr val="lt1"/>
-          </a:fontRef>
-        </p:style>
-        <p:txBody>
-          <a:bodyPr rtlCol="0" anchor="ctr" lIns="0" rIns="0"/>
-          <a:lstStyle/>
-          <a:p>
-            <a:pPr algn="ctr"/>
-          </a:p>
-        </p:txBody>
-      </p:sp>
-      <p:sp>
-        <p:nvSpPr>
           <p:cNvPr id="13" name="TextBox 12"/>
           <p:cNvSpPr txBox="1"/>
           <p:nvPr/>
@@ -23515,50 +22019,6 @@
             <a:solidFill>
               <a:srgbClr val="E4E4E0"/>
             </a:solidFill>
-          </a:ln>
-          <a:effectLst/>
-        </p:spPr>
-        <p:style>
-          <a:lnRef idx="1">
-            <a:schemeClr val="accent1"/>
-          </a:lnRef>
-          <a:fillRef idx="3">
-            <a:schemeClr val="accent1"/>
-          </a:fillRef>
-          <a:effectRef idx="2">
-            <a:schemeClr val="accent1"/>
-          </a:effectRef>
-          <a:fontRef idx="minor">
-            <a:schemeClr val="lt1"/>
-          </a:fontRef>
-        </p:style>
-        <p:txBody>
-          <a:bodyPr rtlCol="0" anchor="ctr" lIns="0" rIns="0"/>
-          <a:lstStyle/>
-          <a:p>
-            <a:pPr algn="ctr"/>
-          </a:p>
-        </p:txBody>
-      </p:sp>
-      <p:sp>
-        <p:nvSpPr>
-          <p:cNvPr id="17" name="Rectangle 16"/>
-          <p:cNvSpPr/>
-          <p:nvPr/>
-        </p:nvSpPr>
-        <p:spPr>
-          <a:xfrm>
-            <a:off x="8083296" y="2157984"/>
-            <a:ext cx="91440" cy="1024128"/>
-          </a:xfrm>
-          <a:prstGeom prst="rect">
-            <a:avLst/>
-          </a:prstGeom>
-          <a:solidFill>
-            <a:srgbClr val="EA493F"/>
-          </a:solidFill>
-          <a:ln>
-            <a:noFill/>
           </a:ln>
           <a:effectLst/>
         </p:spPr>
@@ -37321,50 +35781,6 @@
       </p:sp>
       <p:sp>
         <p:nvSpPr>
-          <p:cNvPr id="7" name="Rectangle 6"/>
-          <p:cNvSpPr/>
-          <p:nvPr/>
-        </p:nvSpPr>
-        <p:spPr>
-          <a:xfrm>
-            <a:off x="877824" y="2121408"/>
-            <a:ext cx="91440" cy="1627632"/>
-          </a:xfrm>
-          <a:prstGeom prst="rect">
-            <a:avLst/>
-          </a:prstGeom>
-          <a:solidFill>
-            <a:srgbClr val="EA493F"/>
-          </a:solidFill>
-          <a:ln>
-            <a:noFill/>
-          </a:ln>
-          <a:effectLst/>
-        </p:spPr>
-        <p:style>
-          <a:lnRef idx="1">
-            <a:schemeClr val="accent1"/>
-          </a:lnRef>
-          <a:fillRef idx="3">
-            <a:schemeClr val="accent1"/>
-          </a:fillRef>
-          <a:effectRef idx="2">
-            <a:schemeClr val="accent1"/>
-          </a:effectRef>
-          <a:fontRef idx="minor">
-            <a:schemeClr val="lt1"/>
-          </a:fontRef>
-        </p:style>
-        <p:txBody>
-          <a:bodyPr rtlCol="0" anchor="ctr" lIns="0" rIns="0"/>
-          <a:lstStyle/>
-          <a:p>
-            <a:pPr algn="ctr"/>
-          </a:p>
-        </p:txBody>
-      </p:sp>
-      <p:sp>
-        <p:nvSpPr>
           <p:cNvPr id="8" name="TextBox 7"/>
           <p:cNvSpPr txBox="1"/>
           <p:nvPr/>
@@ -37493,50 +35909,6 @@
             <a:solidFill>
               <a:srgbClr val="E4E4E0"/>
             </a:solidFill>
-          </a:ln>
-          <a:effectLst/>
-        </p:spPr>
-        <p:style>
-          <a:lnRef idx="1">
-            <a:schemeClr val="accent1"/>
-          </a:lnRef>
-          <a:fillRef idx="3">
-            <a:schemeClr val="accent1"/>
-          </a:fillRef>
-          <a:effectRef idx="2">
-            <a:schemeClr val="accent1"/>
-          </a:effectRef>
-          <a:fontRef idx="minor">
-            <a:schemeClr val="lt1"/>
-          </a:fontRef>
-        </p:style>
-        <p:txBody>
-          <a:bodyPr rtlCol="0" anchor="ctr" lIns="0" rIns="0"/>
-          <a:lstStyle/>
-          <a:p>
-            <a:pPr algn="ctr"/>
-          </a:p>
-        </p:txBody>
-      </p:sp>
-      <p:sp>
-        <p:nvSpPr>
-          <p:cNvPr id="12" name="Rectangle 11"/>
-          <p:cNvSpPr/>
-          <p:nvPr/>
-        </p:nvSpPr>
-        <p:spPr>
-          <a:xfrm>
-            <a:off x="6291072" y="2121408"/>
-            <a:ext cx="91440" cy="1627632"/>
-          </a:xfrm>
-          <a:prstGeom prst="rect">
-            <a:avLst/>
-          </a:prstGeom>
-          <a:solidFill>
-            <a:srgbClr val="111111"/>
-          </a:solidFill>
-          <a:ln>
-            <a:noFill/>
           </a:ln>
           <a:effectLst/>
         </p:spPr>

</xml_diff>